<commit_message>
Refresh demo and presentation materials
</commit_message>
<xml_diff>
--- a/deliverables/Turkish_Legal_RAG_Presentation.pptx
+++ b/deliverables/Turkish_Legal_RAG_Presentation.pptx
@@ -2,22 +2,22 @@
 <file path=ppt/presentation.xml><?xml version="1.0" encoding="utf-8"?>
 <p:presentation xmlns:p="http://schemas.openxmlformats.org/presentationml/2006/main">
   <p:sldMasterIdLst>
-    <p:sldMasterId xmlns:r="http://schemas.openxmlformats.org/officeDocument/2006/relationships" id="2147483648" r:id="R39c8c8d2c13c45e6"/>
+    <p:sldMasterId xmlns:r="http://schemas.openxmlformats.org/officeDocument/2006/relationships" id="2147483648" r:id="R772a9bbc44104829"/>
   </p:sldMasterIdLst>
   <p:notesMasterIdLst>
-    <p:notesMasterId xmlns:r="http://schemas.openxmlformats.org/officeDocument/2006/relationships" r:id="Re1d5bbcb4f844d82"/>
+    <p:notesMasterId xmlns:r="http://schemas.openxmlformats.org/officeDocument/2006/relationships" r:id="Ra99e25f082234d4f"/>
   </p:notesMasterIdLst>
   <p:sldIdLst>
-    <p:sldId xmlns:r="http://schemas.openxmlformats.org/officeDocument/2006/relationships" id="256" r:id="Rfb36fa9e39954325"/>
-    <p:sldId xmlns:r="http://schemas.openxmlformats.org/officeDocument/2006/relationships" id="257" r:id="R275cf84d006c4ec9"/>
-    <p:sldId xmlns:r="http://schemas.openxmlformats.org/officeDocument/2006/relationships" id="258" r:id="R6b3900f986b2408e"/>
-    <p:sldId xmlns:r="http://schemas.openxmlformats.org/officeDocument/2006/relationships" id="259" r:id="R13f9f5c8abbc4b65"/>
-    <p:sldId xmlns:r="http://schemas.openxmlformats.org/officeDocument/2006/relationships" id="260" r:id="R3776e1896519495c"/>
-    <p:sldId xmlns:r="http://schemas.openxmlformats.org/officeDocument/2006/relationships" id="261" r:id="R902a7a2254a24a0b"/>
-    <p:sldId xmlns:r="http://schemas.openxmlformats.org/officeDocument/2006/relationships" id="262" r:id="R43774bd39b90445f"/>
-    <p:sldId xmlns:r="http://schemas.openxmlformats.org/officeDocument/2006/relationships" id="263" r:id="R5a3751e2e34c429f"/>
-    <p:sldId xmlns:r="http://schemas.openxmlformats.org/officeDocument/2006/relationships" id="264" r:id="Rd7b9e93dfb19422b"/>
-    <p:sldId xmlns:r="http://schemas.openxmlformats.org/officeDocument/2006/relationships" id="265" r:id="Rd6cf61af50aa433e"/>
+    <p:sldId xmlns:r="http://schemas.openxmlformats.org/officeDocument/2006/relationships" id="256" r:id="R17f5897ad8004b43"/>
+    <p:sldId xmlns:r="http://schemas.openxmlformats.org/officeDocument/2006/relationships" id="257" r:id="R09eb21072b264ef5"/>
+    <p:sldId xmlns:r="http://schemas.openxmlformats.org/officeDocument/2006/relationships" id="258" r:id="R3353b5e31bad4a79"/>
+    <p:sldId xmlns:r="http://schemas.openxmlformats.org/officeDocument/2006/relationships" id="259" r:id="Rb8f411775fba41e1"/>
+    <p:sldId xmlns:r="http://schemas.openxmlformats.org/officeDocument/2006/relationships" id="260" r:id="Re4fc3c7f92fc411c"/>
+    <p:sldId xmlns:r="http://schemas.openxmlformats.org/officeDocument/2006/relationships" id="261" r:id="Rc8946a4cb9f348b7"/>
+    <p:sldId xmlns:r="http://schemas.openxmlformats.org/officeDocument/2006/relationships" id="262" r:id="R1abc75af5feb40cd"/>
+    <p:sldId xmlns:r="http://schemas.openxmlformats.org/officeDocument/2006/relationships" id="263" r:id="R314a02568da4427b"/>
+    <p:sldId xmlns:r="http://schemas.openxmlformats.org/officeDocument/2006/relationships" id="264" r:id="Rac94f07adde74345"/>
+    <p:sldId xmlns:r="http://schemas.openxmlformats.org/officeDocument/2006/relationships" id="265" r:id="R86a375cd6d1d4ba6"/>
   </p:sldIdLst>
   <p:sldSz cx="12192000" cy="6858000"/>
   <p:notesSz cx="6858000" cy="9144000"/>
@@ -1158,7 +1158,7 @@
   </p:cSld>
   <p:clrMap bg1="lt1" tx1="dk1" bg2="lt2" tx2="dk2" accent1="accent1" accent2="accent2" accent3="accent3" accent4="accent4" accent5="accent5" accent6="accent6" hlink="hlink" folHlink="folHlink"/>
   <p:sldLayoutIdLst>
-    <p:sldLayoutId xmlns:r="http://schemas.openxmlformats.org/officeDocument/2006/relationships" id="2147483649" r:id="R798a08f837ef4a5d"/>
+    <p:sldLayoutId xmlns:r="http://schemas.openxmlformats.org/officeDocument/2006/relationships" id="2147483649" r:id="Rcb3b060a4e444cac"/>
   </p:sldLayoutIdLst>
   <p:txStyles>
     <p:titleStyle>
@@ -1457,7 +1457,7 @@
           <p:cNvPr id="1" name="">
             <a:extLst xmlns:a="http://schemas.openxmlformats.org/drawingml/2006/main">
               <a:ext uri="{FF2B5EF4-FFF2-40B4-BE49-F238E27FC236}">
-                <a16:creationId xmlns:a16="http://schemas.microsoft.com/office/drawing/2014/main" id="{3DC1C883-F943-4D52-9051-6B2D80AAD24F}"/>
+                <a16:creationId xmlns:a16="http://schemas.microsoft.com/office/drawing/2014/main" id="{FD92E3DC-132D-40CE-8AA1-5C8E684A9E04}"/>
               </a:ext>
             </a:extLst>
           </p:cNvPr>
@@ -1490,7 +1490,7 @@
           <p:cNvPr id="2" name="">
             <a:extLst xmlns:a="http://schemas.openxmlformats.org/drawingml/2006/main">
               <a:ext uri="{FF2B5EF4-FFF2-40B4-BE49-F238E27FC236}">
-                <a16:creationId xmlns:a16="http://schemas.microsoft.com/office/drawing/2014/main" id="{CE23263C-7402-4F4C-A941-744503234016}"/>
+                <a16:creationId xmlns:a16="http://schemas.microsoft.com/office/drawing/2014/main" id="{5221A79B-8C64-496A-B909-B94DD2BB1AFD}"/>
               </a:ext>
             </a:extLst>
           </p:cNvPr>
@@ -1550,7 +1550,7 @@
           <p:cNvPr id="3" name="">
             <a:extLst xmlns:a="http://schemas.openxmlformats.org/drawingml/2006/main">
               <a:ext uri="{FF2B5EF4-FFF2-40B4-BE49-F238E27FC236}">
-                <a16:creationId xmlns:a16="http://schemas.microsoft.com/office/drawing/2014/main" id="{E2A44011-087E-4DA2-8212-9998BF59E289}"/>
+                <a16:creationId xmlns:a16="http://schemas.microsoft.com/office/drawing/2014/main" id="{3840CE96-BAD3-42AF-A0ED-1C1E94EB9088}"/>
               </a:ext>
             </a:extLst>
           </p:cNvPr>
@@ -1610,7 +1610,7 @@
           <p:cNvPr id="4" name="">
             <a:extLst xmlns:a="http://schemas.openxmlformats.org/drawingml/2006/main">
               <a:ext uri="{FF2B5EF4-FFF2-40B4-BE49-F238E27FC236}">
-                <a16:creationId xmlns:a16="http://schemas.microsoft.com/office/drawing/2014/main" id="{BD87A3AD-147E-40B0-810C-D06D304345BB}"/>
+                <a16:creationId xmlns:a16="http://schemas.microsoft.com/office/drawing/2014/main" id="{768044E0-FF13-4B0B-9464-9F791923D08E}"/>
               </a:ext>
             </a:extLst>
           </p:cNvPr>
@@ -1670,7 +1670,7 @@
           <p:cNvPr id="5" name="">
             <a:extLst xmlns:a="http://schemas.openxmlformats.org/drawingml/2006/main">
               <a:ext uri="{FF2B5EF4-FFF2-40B4-BE49-F238E27FC236}">
-                <a16:creationId xmlns:a16="http://schemas.microsoft.com/office/drawing/2014/main" id="{10CDFE6F-0D7E-42AB-9F6F-79716C3B286E}"/>
+                <a16:creationId xmlns:a16="http://schemas.microsoft.com/office/drawing/2014/main" id="{53966C81-D2D7-4778-95C3-18839114E1D5}"/>
               </a:ext>
             </a:extLst>
           </p:cNvPr>
@@ -1703,7 +1703,7 @@
           <p:cNvPr id="6" name="">
             <a:extLst xmlns:a="http://schemas.openxmlformats.org/drawingml/2006/main">
               <a:ext uri="{FF2B5EF4-FFF2-40B4-BE49-F238E27FC236}">
-                <a16:creationId xmlns:a16="http://schemas.microsoft.com/office/drawing/2014/main" id="{65D8F09F-244E-42E8-B92E-226F993A5ED2}"/>
+                <a16:creationId xmlns:a16="http://schemas.microsoft.com/office/drawing/2014/main" id="{4D4E3BF8-42CE-41F6-9E03-E32882DCD67D}"/>
               </a:ext>
             </a:extLst>
           </p:cNvPr>
@@ -1763,7 +1763,7 @@
           <p:cNvPr id="7" name="">
             <a:extLst xmlns:a="http://schemas.openxmlformats.org/drawingml/2006/main">
               <a:ext uri="{FF2B5EF4-FFF2-40B4-BE49-F238E27FC236}">
-                <a16:creationId xmlns:a16="http://schemas.microsoft.com/office/drawing/2014/main" id="{613D61DB-EC52-4CD5-9323-32C5328614E2}"/>
+                <a16:creationId xmlns:a16="http://schemas.microsoft.com/office/drawing/2014/main" id="{82AAB1EA-702B-4E1C-B46A-089DA630AAD3}"/>
               </a:ext>
             </a:extLst>
           </p:cNvPr>
@@ -1823,7 +1823,7 @@
           <p:cNvPr id="8" name="">
             <a:extLst xmlns:a="http://schemas.openxmlformats.org/drawingml/2006/main">
               <a:ext uri="{FF2B5EF4-FFF2-40B4-BE49-F238E27FC236}">
-                <a16:creationId xmlns:a16="http://schemas.microsoft.com/office/drawing/2014/main" id="{FDCCAF08-9561-4C37-8C4E-F8632E463662}"/>
+                <a16:creationId xmlns:a16="http://schemas.microsoft.com/office/drawing/2014/main" id="{0FB38769-C470-4B29-A6DF-AB78B5E6CD58}"/>
               </a:ext>
             </a:extLst>
           </p:cNvPr>
@@ -1856,7 +1856,7 @@
           <p:cNvPr id="9" name="">
             <a:extLst xmlns:a="http://schemas.openxmlformats.org/drawingml/2006/main">
               <a:ext uri="{FF2B5EF4-FFF2-40B4-BE49-F238E27FC236}">
-                <a16:creationId xmlns:a16="http://schemas.microsoft.com/office/drawing/2014/main" id="{022D2321-29A4-4106-89F9-7033FE454C25}"/>
+                <a16:creationId xmlns:a16="http://schemas.microsoft.com/office/drawing/2014/main" id="{0854C951-5015-4CE1-A975-9B3BE7692CE2}"/>
               </a:ext>
             </a:extLst>
           </p:cNvPr>
@@ -1916,7 +1916,7 @@
           <p:cNvPr id="10" name="">
             <a:extLst xmlns:a="http://schemas.openxmlformats.org/drawingml/2006/main">
               <a:ext uri="{FF2B5EF4-FFF2-40B4-BE49-F238E27FC236}">
-                <a16:creationId xmlns:a16="http://schemas.microsoft.com/office/drawing/2014/main" id="{D3CB4FF2-4299-4D47-886A-692C7A632CEB}"/>
+                <a16:creationId xmlns:a16="http://schemas.microsoft.com/office/drawing/2014/main" id="{AB0E6D7E-DD42-479F-9681-70DB2B8DB8C8}"/>
               </a:ext>
             </a:extLst>
           </p:cNvPr>
@@ -1976,7 +1976,7 @@
           <p:cNvPr id="11" name="">
             <a:extLst xmlns:a="http://schemas.openxmlformats.org/drawingml/2006/main">
               <a:ext uri="{FF2B5EF4-FFF2-40B4-BE49-F238E27FC236}">
-                <a16:creationId xmlns:a16="http://schemas.microsoft.com/office/drawing/2014/main" id="{EFE08554-0F0B-4698-BE88-15687398CA99}"/>
+                <a16:creationId xmlns:a16="http://schemas.microsoft.com/office/drawing/2014/main" id="{5F70FD31-A8FC-4AD4-8353-3710DC8E6B0F}"/>
               </a:ext>
             </a:extLst>
           </p:cNvPr>
@@ -2009,7 +2009,7 @@
           <p:cNvPr id="12" name="">
             <a:extLst xmlns:a="http://schemas.openxmlformats.org/drawingml/2006/main">
               <a:ext uri="{FF2B5EF4-FFF2-40B4-BE49-F238E27FC236}">
-                <a16:creationId xmlns:a16="http://schemas.microsoft.com/office/drawing/2014/main" id="{6B52530D-0522-489B-A82E-CC411E6FB95F}"/>
+                <a16:creationId xmlns:a16="http://schemas.microsoft.com/office/drawing/2014/main" id="{57E32476-A46B-4660-B433-DE0368C6C1EC}"/>
               </a:ext>
             </a:extLst>
           </p:cNvPr>
@@ -2069,7 +2069,7 @@
           <p:cNvPr id="13" name="">
             <a:extLst xmlns:a="http://schemas.openxmlformats.org/drawingml/2006/main">
               <a:ext uri="{FF2B5EF4-FFF2-40B4-BE49-F238E27FC236}">
-                <a16:creationId xmlns:a16="http://schemas.microsoft.com/office/drawing/2014/main" id="{6663FFC8-7982-4FA1-8A3D-02B96061F3D9}"/>
+                <a16:creationId xmlns:a16="http://schemas.microsoft.com/office/drawing/2014/main" id="{CA1DD927-0D74-42D9-8F42-3DA637BAC484}"/>
               </a:ext>
             </a:extLst>
           </p:cNvPr>
@@ -2129,7 +2129,7 @@
           <p:cNvPr id="14" name="">
             <a:extLst xmlns:a="http://schemas.openxmlformats.org/drawingml/2006/main">
               <a:ext uri="{FF2B5EF4-FFF2-40B4-BE49-F238E27FC236}">
-                <a16:creationId xmlns:a16="http://schemas.microsoft.com/office/drawing/2014/main" id="{3F042C79-E1DC-409E-9AF2-D28F8798B159}"/>
+                <a16:creationId xmlns:a16="http://schemas.microsoft.com/office/drawing/2014/main" id="{2DCD849C-5D48-41D3-824E-208B19765127}"/>
               </a:ext>
             </a:extLst>
           </p:cNvPr>
@@ -2162,7 +2162,7 @@
           <p:cNvPr id="15" name="">
             <a:extLst xmlns:a="http://schemas.openxmlformats.org/drawingml/2006/main">
               <a:ext uri="{FF2B5EF4-FFF2-40B4-BE49-F238E27FC236}">
-                <a16:creationId xmlns:a16="http://schemas.microsoft.com/office/drawing/2014/main" id="{CEE5384A-F0BE-460D-AC8B-27249E804754}"/>
+                <a16:creationId xmlns:a16="http://schemas.microsoft.com/office/drawing/2014/main" id="{AD0FCC58-2638-4199-8813-D93E745E011F}"/>
               </a:ext>
             </a:extLst>
           </p:cNvPr>
@@ -2222,7 +2222,7 @@
           <p:cNvPr id="16" name="">
             <a:extLst xmlns:a="http://schemas.openxmlformats.org/drawingml/2006/main">
               <a:ext uri="{FF2B5EF4-FFF2-40B4-BE49-F238E27FC236}">
-                <a16:creationId xmlns:a16="http://schemas.microsoft.com/office/drawing/2014/main" id="{AECD4AE7-AF92-448E-9580-07A850C7F64D}"/>
+                <a16:creationId xmlns:a16="http://schemas.microsoft.com/office/drawing/2014/main" id="{ECEDEA55-000F-4FAA-94F4-64CD9DFBF797}"/>
               </a:ext>
             </a:extLst>
           </p:cNvPr>
@@ -2282,7 +2282,7 @@
           <p:cNvPr id="17" name="">
             <a:extLst xmlns:a="http://schemas.openxmlformats.org/drawingml/2006/main">
               <a:ext uri="{FF2B5EF4-FFF2-40B4-BE49-F238E27FC236}">
-                <a16:creationId xmlns:a16="http://schemas.microsoft.com/office/drawing/2014/main" id="{AD3917D6-BB40-4132-B01C-18B248BDBD97}"/>
+                <a16:creationId xmlns:a16="http://schemas.microsoft.com/office/drawing/2014/main" id="{57F91DC8-A984-4572-8938-5AB01D91A0BF}"/>
               </a:ext>
             </a:extLst>
           </p:cNvPr>
@@ -2340,7 +2340,7 @@
     </p:spTree>
     <p:extLst>
       <p:ext uri="{BB962C8B-B14F-4D97-AF65-F5344CB8AC3E}">
-        <p14:creationId xmlns:p14="http://schemas.microsoft.com/office/powerpoint/2010/main" val="931933011"/>
+        <p14:creationId xmlns:p14="http://schemas.microsoft.com/office/powerpoint/2010/main" val="1183162616"/>
       </p:ext>
     </p:extLst>
   </p:cSld>
@@ -2364,7 +2364,7 @@
           <p:cNvPr id="1" name="">
             <a:extLst xmlns:a="http://schemas.openxmlformats.org/drawingml/2006/main">
               <a:ext uri="{FF2B5EF4-FFF2-40B4-BE49-F238E27FC236}">
-                <a16:creationId xmlns:a16="http://schemas.microsoft.com/office/drawing/2014/main" id="{ED9756EB-DE37-4A82-8CC6-8DEE7FD2CBFD}"/>
+                <a16:creationId xmlns:a16="http://schemas.microsoft.com/office/drawing/2014/main" id="{D627D813-3C28-4282-BB96-19E8B4D7CC74}"/>
               </a:ext>
             </a:extLst>
           </p:cNvPr>
@@ -2424,7 +2424,7 @@
           <p:cNvPr id="2" name="">
             <a:extLst xmlns:a="http://schemas.openxmlformats.org/drawingml/2006/main">
               <a:ext uri="{FF2B5EF4-FFF2-40B4-BE49-F238E27FC236}">
-                <a16:creationId xmlns:a16="http://schemas.microsoft.com/office/drawing/2014/main" id="{7D1D8619-6664-4DC9-9FE0-F0C8139118FD}"/>
+                <a16:creationId xmlns:a16="http://schemas.microsoft.com/office/drawing/2014/main" id="{512D0D3C-35B2-4489-81DB-1E11208A326E}"/>
               </a:ext>
             </a:extLst>
           </p:cNvPr>
@@ -2474,7 +2474,7 @@
                 <a:ea typeface="Aptos"/>
                 <a:cs typeface="Aptos"/>
               </a:rPr>
-              <a:t>The project is reproducible and identifies the next optimization targets.</a:t>
+              <a:t>The project is reproducible, measured, and demo-ready.</a:t>
             </a:r>
           </a:p>
         </p:txBody>
@@ -2484,7 +2484,7 @@
           <p:cNvPr id="3" name="">
             <a:extLst xmlns:a="http://schemas.openxmlformats.org/drawingml/2006/main">
               <a:ext uri="{FF2B5EF4-FFF2-40B4-BE49-F238E27FC236}">
-                <a16:creationId xmlns:a16="http://schemas.microsoft.com/office/drawing/2014/main" id="{3B662518-A99B-4F38-B0A0-EEF9CBC8AE65}"/>
+                <a16:creationId xmlns:a16="http://schemas.microsoft.com/office/drawing/2014/main" id="{DC53BAE0-F726-4823-930F-F65C077C317A}"/>
               </a:ext>
             </a:extLst>
           </p:cNvPr>
@@ -2517,7 +2517,7 @@
           <p:cNvPr id="4" name="">
             <a:extLst xmlns:a="http://schemas.openxmlformats.org/drawingml/2006/main">
               <a:ext uri="{FF2B5EF4-FFF2-40B4-BE49-F238E27FC236}">
-                <a16:creationId xmlns:a16="http://schemas.microsoft.com/office/drawing/2014/main" id="{644997C4-67A3-4ACA-B8AF-DC260F2ACE10}"/>
+                <a16:creationId xmlns:a16="http://schemas.microsoft.com/office/drawing/2014/main" id="{60EDCD89-68CB-440F-A1A3-134017379045}"/>
               </a:ext>
             </a:extLst>
           </p:cNvPr>
@@ -2550,7 +2550,7 @@
           <p:cNvPr id="5" name="">
             <a:extLst xmlns:a="http://schemas.openxmlformats.org/drawingml/2006/main">
               <a:ext uri="{FF2B5EF4-FFF2-40B4-BE49-F238E27FC236}">
-                <a16:creationId xmlns:a16="http://schemas.microsoft.com/office/drawing/2014/main" id="{1C364141-3A5F-4711-9287-EDDCF0199333}"/>
+                <a16:creationId xmlns:a16="http://schemas.microsoft.com/office/drawing/2014/main" id="{BF890920-EF5A-40D4-8301-9E1188497163}"/>
               </a:ext>
             </a:extLst>
           </p:cNvPr>
@@ -2610,7 +2610,7 @@
           <p:cNvPr id="6" name="">
             <a:extLst xmlns:a="http://schemas.openxmlformats.org/drawingml/2006/main">
               <a:ext uri="{FF2B5EF4-FFF2-40B4-BE49-F238E27FC236}">
-                <a16:creationId xmlns:a16="http://schemas.microsoft.com/office/drawing/2014/main" id="{4E4B4525-5AA1-4DAC-93F3-77713F6DA7A0}"/>
+                <a16:creationId xmlns:a16="http://schemas.microsoft.com/office/drawing/2014/main" id="{97DFF9A0-1113-49DC-B0E1-F564A6BC5B1A}"/>
               </a:ext>
             </a:extLst>
           </p:cNvPr>
@@ -2643,7 +2643,7 @@
           <p:cNvPr id="7" name="">
             <a:extLst xmlns:a="http://schemas.openxmlformats.org/drawingml/2006/main">
               <a:ext uri="{FF2B5EF4-FFF2-40B4-BE49-F238E27FC236}">
-                <a16:creationId xmlns:a16="http://schemas.microsoft.com/office/drawing/2014/main" id="{764E68E2-C858-4CAE-9121-1E5FEB48470B}"/>
+                <a16:creationId xmlns:a16="http://schemas.microsoft.com/office/drawing/2014/main" id="{845BE335-16FB-4C8E-87E5-73484298019A}"/>
               </a:ext>
             </a:extLst>
           </p:cNvPr>
@@ -2693,7 +2693,7 @@
                 <a:ea typeface="Aptos"/>
                 <a:cs typeface="Aptos"/>
               </a:rPr>
-              <a:t>Generic dense embeddings underperform in Turkish legal retrieval.</a:t>
+              <a:t>Embedding and reranker fine-tuning were run and evaluated on CPU.</a:t>
             </a:r>
           </a:p>
         </p:txBody>
@@ -2703,7 +2703,7 @@
           <p:cNvPr id="8" name="">
             <a:extLst xmlns:a="http://schemas.openxmlformats.org/drawingml/2006/main">
               <a:ext uri="{FF2B5EF4-FFF2-40B4-BE49-F238E27FC236}">
-                <a16:creationId xmlns:a16="http://schemas.microsoft.com/office/drawing/2014/main" id="{7CDE6016-F96D-47BB-8576-4638CAE79C28}"/>
+                <a16:creationId xmlns:a16="http://schemas.microsoft.com/office/drawing/2014/main" id="{E4E5F07A-1633-45F0-9138-83F5ED9B5F68}"/>
               </a:ext>
             </a:extLst>
           </p:cNvPr>
@@ -2736,7 +2736,7 @@
           <p:cNvPr id="9" name="">
             <a:extLst xmlns:a="http://schemas.openxmlformats.org/drawingml/2006/main">
               <a:ext uri="{FF2B5EF4-FFF2-40B4-BE49-F238E27FC236}">
-                <a16:creationId xmlns:a16="http://schemas.microsoft.com/office/drawing/2014/main" id="{19B0CDA7-F7D4-4A04-B79A-9201E3AF3C1F}"/>
+                <a16:creationId xmlns:a16="http://schemas.microsoft.com/office/drawing/2014/main" id="{68E10B2E-AF64-4B35-B707-41FFBDF22D5B}"/>
               </a:ext>
             </a:extLst>
           </p:cNvPr>
@@ -2786,7 +2786,7 @@
                 <a:ea typeface="Aptos"/>
                 <a:cs typeface="Aptos"/>
               </a:rPr>
-              <a:t>General-domain reranking hurts without legal fine-tuning.</a:t>
+              <a:t>LLM/SFT smoke training works but is not reliable enough for live demo.</a:t>
             </a:r>
           </a:p>
         </p:txBody>
@@ -2796,7 +2796,7 @@
           <p:cNvPr id="10" name="">
             <a:extLst xmlns:a="http://schemas.openxmlformats.org/drawingml/2006/main">
               <a:ext uri="{FF2B5EF4-FFF2-40B4-BE49-F238E27FC236}">
-                <a16:creationId xmlns:a16="http://schemas.microsoft.com/office/drawing/2014/main" id="{BED06375-E366-416A-9B66-C8005438F9A3}"/>
+                <a16:creationId xmlns:a16="http://schemas.microsoft.com/office/drawing/2014/main" id="{0E2560C3-7399-434B-9775-03E07B1E48D7}"/>
               </a:ext>
             </a:extLst>
           </p:cNvPr>
@@ -2829,7 +2829,7 @@
           <p:cNvPr id="11" name="">
             <a:extLst xmlns:a="http://schemas.openxmlformats.org/drawingml/2006/main">
               <a:ext uri="{FF2B5EF4-FFF2-40B4-BE49-F238E27FC236}">
-                <a16:creationId xmlns:a16="http://schemas.microsoft.com/office/drawing/2014/main" id="{576C20C9-D1D4-485C-97E9-97A91CA405F7}"/>
+                <a16:creationId xmlns:a16="http://schemas.microsoft.com/office/drawing/2014/main" id="{83D268D0-3A00-46B4-BF01-B2330E0115AF}"/>
               </a:ext>
             </a:extLst>
           </p:cNvPr>
@@ -2879,7 +2879,7 @@
                 <a:ea typeface="Aptos"/>
                 <a:cs typeface="Aptos"/>
               </a:rPr>
-              <a:t>Error analysis tells us where to optimize next.</a:t>
+              <a:t>Judge faithfulness and error analysis make grounding auditable.</a:t>
             </a:r>
           </a:p>
         </p:txBody>
@@ -2889,7 +2889,7 @@
           <p:cNvPr id="12" name="">
             <a:extLst xmlns:a="http://schemas.openxmlformats.org/drawingml/2006/main">
               <a:ext uri="{FF2B5EF4-FFF2-40B4-BE49-F238E27FC236}">
-                <a16:creationId xmlns:a16="http://schemas.microsoft.com/office/drawing/2014/main" id="{B7755C48-4DB0-4BB9-9EE8-CFF547485AE3}"/>
+                <a16:creationId xmlns:a16="http://schemas.microsoft.com/office/drawing/2014/main" id="{68935222-92FB-482E-8387-7A69CCCE0ACD}"/>
               </a:ext>
             </a:extLst>
           </p:cNvPr>
@@ -2947,7 +2947,7 @@
     </p:spTree>
     <p:extLst>
       <p:ext uri="{BB962C8B-B14F-4D97-AF65-F5344CB8AC3E}">
-        <p14:creationId xmlns:p14="http://schemas.microsoft.com/office/powerpoint/2010/main" val="780669388"/>
+        <p14:creationId xmlns:p14="http://schemas.microsoft.com/office/powerpoint/2010/main" val="1065589329"/>
       </p:ext>
     </p:extLst>
   </p:cSld>
@@ -2971,7 +2971,7 @@
           <p:cNvPr id="1" name="">
             <a:extLst xmlns:a="http://schemas.openxmlformats.org/drawingml/2006/main">
               <a:ext uri="{FF2B5EF4-FFF2-40B4-BE49-F238E27FC236}">
-                <a16:creationId xmlns:a16="http://schemas.microsoft.com/office/drawing/2014/main" id="{6FFEFBB2-9780-4361-8ED3-4FF60F43B598}"/>
+                <a16:creationId xmlns:a16="http://schemas.microsoft.com/office/drawing/2014/main" id="{7B26A999-417E-4883-BE53-A2B050649C06}"/>
               </a:ext>
             </a:extLst>
           </p:cNvPr>
@@ -3031,7 +3031,7 @@
           <p:cNvPr id="2" name="">
             <a:extLst xmlns:a="http://schemas.openxmlformats.org/drawingml/2006/main">
               <a:ext uri="{FF2B5EF4-FFF2-40B4-BE49-F238E27FC236}">
-                <a16:creationId xmlns:a16="http://schemas.microsoft.com/office/drawing/2014/main" id="{899AC1C0-8736-4646-9960-E862C112F349}"/>
+                <a16:creationId xmlns:a16="http://schemas.microsoft.com/office/drawing/2014/main" id="{99A816E6-DBCB-42B3-ACAF-BAE1A5CA1E1A}"/>
               </a:ext>
             </a:extLst>
           </p:cNvPr>
@@ -3091,7 +3091,7 @@
           <p:cNvPr id="3" name="">
             <a:extLst xmlns:a="http://schemas.openxmlformats.org/drawingml/2006/main">
               <a:ext uri="{FF2B5EF4-FFF2-40B4-BE49-F238E27FC236}">
-                <a16:creationId xmlns:a16="http://schemas.microsoft.com/office/drawing/2014/main" id="{C0FA6D74-862B-42AC-812C-C27BFF70FE7C}"/>
+                <a16:creationId xmlns:a16="http://schemas.microsoft.com/office/drawing/2014/main" id="{3D5B8697-AF0D-4BDA-8F36-5D4460ABF854}"/>
               </a:ext>
             </a:extLst>
           </p:cNvPr>
@@ -3124,7 +3124,7 @@
           <p:cNvPr id="4" name="">
             <a:extLst xmlns:a="http://schemas.openxmlformats.org/drawingml/2006/main">
               <a:ext uri="{FF2B5EF4-FFF2-40B4-BE49-F238E27FC236}">
-                <a16:creationId xmlns:a16="http://schemas.microsoft.com/office/drawing/2014/main" id="{21290266-801D-40F5-B894-719046DDFF11}"/>
+                <a16:creationId xmlns:a16="http://schemas.microsoft.com/office/drawing/2014/main" id="{725C7E40-40E3-42B2-B6BD-6AB87B995B6C}"/>
               </a:ext>
             </a:extLst>
           </p:cNvPr>
@@ -3184,7 +3184,7 @@
           <p:cNvPr id="5" name="">
             <a:extLst xmlns:a="http://schemas.openxmlformats.org/drawingml/2006/main">
               <a:ext uri="{FF2B5EF4-FFF2-40B4-BE49-F238E27FC236}">
-                <a16:creationId xmlns:a16="http://schemas.microsoft.com/office/drawing/2014/main" id="{CDC9321B-3224-4F4A-BC9F-C96DC6C71A7F}"/>
+                <a16:creationId xmlns:a16="http://schemas.microsoft.com/office/drawing/2014/main" id="{6CB10F6B-6E07-4CE7-822C-E010D05AEC7D}"/>
               </a:ext>
             </a:extLst>
           </p:cNvPr>
@@ -3244,7 +3244,7 @@
           <p:cNvPr id="6" name="">
             <a:extLst xmlns:a="http://schemas.openxmlformats.org/drawingml/2006/main">
               <a:ext uri="{FF2B5EF4-FFF2-40B4-BE49-F238E27FC236}">
-                <a16:creationId xmlns:a16="http://schemas.microsoft.com/office/drawing/2014/main" id="{FB4A609D-6237-4254-BB41-8BC34D499E59}"/>
+                <a16:creationId xmlns:a16="http://schemas.microsoft.com/office/drawing/2014/main" id="{011C78AB-3F17-4910-8A19-5161F00ED123}"/>
               </a:ext>
             </a:extLst>
           </p:cNvPr>
@@ -3304,7 +3304,7 @@
           <p:cNvPr id="7" name="">
             <a:extLst xmlns:a="http://schemas.openxmlformats.org/drawingml/2006/main">
               <a:ext uri="{FF2B5EF4-FFF2-40B4-BE49-F238E27FC236}">
-                <a16:creationId xmlns:a16="http://schemas.microsoft.com/office/drawing/2014/main" id="{05079CA4-C3C3-49D7-918E-4C38F86B32F7}"/>
+                <a16:creationId xmlns:a16="http://schemas.microsoft.com/office/drawing/2014/main" id="{69799CF0-FD27-4C47-9887-FBDB2FFB5ADA}"/>
               </a:ext>
             </a:extLst>
           </p:cNvPr>
@@ -3364,7 +3364,7 @@
           <p:cNvPr id="8" name="">
             <a:extLst xmlns:a="http://schemas.openxmlformats.org/drawingml/2006/main">
               <a:ext uri="{FF2B5EF4-FFF2-40B4-BE49-F238E27FC236}">
-                <a16:creationId xmlns:a16="http://schemas.microsoft.com/office/drawing/2014/main" id="{2CABED8B-21BD-418B-A2C0-9A0479AE466B}"/>
+                <a16:creationId xmlns:a16="http://schemas.microsoft.com/office/drawing/2014/main" id="{CEC30063-4BD5-41B1-B5CF-CE611212AE59}"/>
               </a:ext>
             </a:extLst>
           </p:cNvPr>
@@ -3397,7 +3397,7 @@
           <p:cNvPr id="9" name="">
             <a:extLst xmlns:a="http://schemas.openxmlformats.org/drawingml/2006/main">
               <a:ext uri="{FF2B5EF4-FFF2-40B4-BE49-F238E27FC236}">
-                <a16:creationId xmlns:a16="http://schemas.microsoft.com/office/drawing/2014/main" id="{68DBFFDF-B718-4C5D-8DCF-CD8AAF1AD1AD}"/>
+                <a16:creationId xmlns:a16="http://schemas.microsoft.com/office/drawing/2014/main" id="{4B35DBFC-91B5-4A6E-BED4-51D5EF720E96}"/>
               </a:ext>
             </a:extLst>
           </p:cNvPr>
@@ -3457,7 +3457,7 @@
           <p:cNvPr id="10" name="">
             <a:extLst xmlns:a="http://schemas.openxmlformats.org/drawingml/2006/main">
               <a:ext uri="{FF2B5EF4-FFF2-40B4-BE49-F238E27FC236}">
-                <a16:creationId xmlns:a16="http://schemas.microsoft.com/office/drawing/2014/main" id="{0570E689-1B75-468B-AEBC-11775E5DE859}"/>
+                <a16:creationId xmlns:a16="http://schemas.microsoft.com/office/drawing/2014/main" id="{DD6EB0D8-11A6-4EEF-834F-183EF539C3A9}"/>
               </a:ext>
             </a:extLst>
           </p:cNvPr>
@@ -3515,7 +3515,7 @@
     </p:spTree>
     <p:extLst>
       <p:ext uri="{BB962C8B-B14F-4D97-AF65-F5344CB8AC3E}">
-        <p14:creationId xmlns:p14="http://schemas.microsoft.com/office/powerpoint/2010/main" val="224865536"/>
+        <p14:creationId xmlns:p14="http://schemas.microsoft.com/office/powerpoint/2010/main" val="290862905"/>
       </p:ext>
     </p:extLst>
   </p:cSld>
@@ -3539,7 +3539,7 @@
           <p:cNvPr id="1" name="">
             <a:extLst xmlns:a="http://schemas.openxmlformats.org/drawingml/2006/main">
               <a:ext uri="{FF2B5EF4-FFF2-40B4-BE49-F238E27FC236}">
-                <a16:creationId xmlns:a16="http://schemas.microsoft.com/office/drawing/2014/main" id="{1D5347DA-66CD-4B09-AB09-7968FC3D801B}"/>
+                <a16:creationId xmlns:a16="http://schemas.microsoft.com/office/drawing/2014/main" id="{CC9207D9-CB65-4B13-A0D4-70E193C311BD}"/>
               </a:ext>
             </a:extLst>
           </p:cNvPr>
@@ -3599,7 +3599,7 @@
           <p:cNvPr id="2" name="">
             <a:extLst xmlns:a="http://schemas.openxmlformats.org/drawingml/2006/main">
               <a:ext uri="{FF2B5EF4-FFF2-40B4-BE49-F238E27FC236}">
-                <a16:creationId xmlns:a16="http://schemas.microsoft.com/office/drawing/2014/main" id="{32BEB5BF-1EFB-4F3E-AAF3-67416FCD93BE}"/>
+                <a16:creationId xmlns:a16="http://schemas.microsoft.com/office/drawing/2014/main" id="{FF6C62CA-3CAF-4AC4-BAB7-AE0E722C81F5}"/>
               </a:ext>
             </a:extLst>
           </p:cNvPr>
@@ -3659,7 +3659,7 @@
           <p:cNvPr id="3" name="">
             <a:extLst xmlns:a="http://schemas.openxmlformats.org/drawingml/2006/main">
               <a:ext uri="{FF2B5EF4-FFF2-40B4-BE49-F238E27FC236}">
-                <a16:creationId xmlns:a16="http://schemas.microsoft.com/office/drawing/2014/main" id="{D66523D0-55C8-4F0E-A28E-B6A2D8808E1C}"/>
+                <a16:creationId xmlns:a16="http://schemas.microsoft.com/office/drawing/2014/main" id="{DAE3DFCA-DA13-4EB6-AC9A-603BFEE80332}"/>
               </a:ext>
             </a:extLst>
           </p:cNvPr>
@@ -3692,7 +3692,7 @@
           <p:cNvPr id="4" name="">
             <a:extLst xmlns:a="http://schemas.openxmlformats.org/drawingml/2006/main">
               <a:ext uri="{FF2B5EF4-FFF2-40B4-BE49-F238E27FC236}">
-                <a16:creationId xmlns:a16="http://schemas.microsoft.com/office/drawing/2014/main" id="{6AD398D2-69A5-4A90-B1F5-8891B8EA4C75}"/>
+                <a16:creationId xmlns:a16="http://schemas.microsoft.com/office/drawing/2014/main" id="{63FDC04C-4634-4A50-9467-6FFE51A556E3}"/>
               </a:ext>
             </a:extLst>
           </p:cNvPr>
@@ -3725,7 +3725,7 @@
           <p:cNvPr id="5" name="">
             <a:extLst xmlns:a="http://schemas.openxmlformats.org/drawingml/2006/main">
               <a:ext uri="{FF2B5EF4-FFF2-40B4-BE49-F238E27FC236}">
-                <a16:creationId xmlns:a16="http://schemas.microsoft.com/office/drawing/2014/main" id="{58E2D571-5C08-42E3-BD8D-280214F2B4C6}"/>
+                <a16:creationId xmlns:a16="http://schemas.microsoft.com/office/drawing/2014/main" id="{26D72037-C9F4-41F3-93EF-3591A5CCED7B}"/>
               </a:ext>
             </a:extLst>
           </p:cNvPr>
@@ -3785,7 +3785,7 @@
           <p:cNvPr id="6" name="">
             <a:extLst xmlns:a="http://schemas.openxmlformats.org/drawingml/2006/main">
               <a:ext uri="{FF2B5EF4-FFF2-40B4-BE49-F238E27FC236}">
-                <a16:creationId xmlns:a16="http://schemas.microsoft.com/office/drawing/2014/main" id="{E2E537AC-A2CD-47C4-906D-ABA515F53C5C}"/>
+                <a16:creationId xmlns:a16="http://schemas.microsoft.com/office/drawing/2014/main" id="{66FDC269-DA10-42A8-84ED-42FD8FB227D1}"/>
               </a:ext>
             </a:extLst>
           </p:cNvPr>
@@ -3845,7 +3845,7 @@
           <p:cNvPr id="7" name="">
             <a:extLst xmlns:a="http://schemas.openxmlformats.org/drawingml/2006/main">
               <a:ext uri="{FF2B5EF4-FFF2-40B4-BE49-F238E27FC236}">
-                <a16:creationId xmlns:a16="http://schemas.microsoft.com/office/drawing/2014/main" id="{4827B4FA-9184-4D8C-BA71-64637AA555FF}"/>
+                <a16:creationId xmlns:a16="http://schemas.microsoft.com/office/drawing/2014/main" id="{4741AB45-A23F-41EB-B8FF-9F2CA98C0EDE}"/>
               </a:ext>
             </a:extLst>
           </p:cNvPr>
@@ -3905,7 +3905,7 @@
           <p:cNvPr id="8" name="">
             <a:extLst xmlns:a="http://schemas.openxmlformats.org/drawingml/2006/main">
               <a:ext uri="{FF2B5EF4-FFF2-40B4-BE49-F238E27FC236}">
-                <a16:creationId xmlns:a16="http://schemas.microsoft.com/office/drawing/2014/main" id="{D6C4B0EF-538D-448E-895E-C611670FA4D2}"/>
+                <a16:creationId xmlns:a16="http://schemas.microsoft.com/office/drawing/2014/main" id="{9700EFCA-0B9F-41AA-805E-BFAAAAA95246}"/>
               </a:ext>
             </a:extLst>
           </p:cNvPr>
@@ -3938,7 +3938,7 @@
           <p:cNvPr id="9" name="">
             <a:extLst xmlns:a="http://schemas.openxmlformats.org/drawingml/2006/main">
               <a:ext uri="{FF2B5EF4-FFF2-40B4-BE49-F238E27FC236}">
-                <a16:creationId xmlns:a16="http://schemas.microsoft.com/office/drawing/2014/main" id="{6BDAA10D-26A4-4020-8764-7A97C5D6E3F3}"/>
+                <a16:creationId xmlns:a16="http://schemas.microsoft.com/office/drawing/2014/main" id="{8D586666-4B8E-4C7D-8C25-D5B058E8252B}"/>
               </a:ext>
             </a:extLst>
           </p:cNvPr>
@@ -3998,7 +3998,7 @@
           <p:cNvPr id="10" name="">
             <a:extLst xmlns:a="http://schemas.openxmlformats.org/drawingml/2006/main">
               <a:ext uri="{FF2B5EF4-FFF2-40B4-BE49-F238E27FC236}">
-                <a16:creationId xmlns:a16="http://schemas.microsoft.com/office/drawing/2014/main" id="{2AA7CBAF-0AFE-4F97-88B3-FEE34D0E12A5}"/>
+                <a16:creationId xmlns:a16="http://schemas.microsoft.com/office/drawing/2014/main" id="{40F15E48-87C9-4CBF-B72C-0C8BD74DE669}"/>
               </a:ext>
             </a:extLst>
           </p:cNvPr>
@@ -4058,7 +4058,7 @@
           <p:cNvPr id="11" name="">
             <a:extLst xmlns:a="http://schemas.openxmlformats.org/drawingml/2006/main">
               <a:ext uri="{FF2B5EF4-FFF2-40B4-BE49-F238E27FC236}">
-                <a16:creationId xmlns:a16="http://schemas.microsoft.com/office/drawing/2014/main" id="{76D31352-4B19-49AC-B268-88C21007F0A8}"/>
+                <a16:creationId xmlns:a16="http://schemas.microsoft.com/office/drawing/2014/main" id="{9100432F-5CB2-47DD-9F2A-D27E72C2FB33}"/>
               </a:ext>
             </a:extLst>
           </p:cNvPr>
@@ -4118,7 +4118,7 @@
           <p:cNvPr id="12" name="">
             <a:extLst xmlns:a="http://schemas.openxmlformats.org/drawingml/2006/main">
               <a:ext uri="{FF2B5EF4-FFF2-40B4-BE49-F238E27FC236}">
-                <a16:creationId xmlns:a16="http://schemas.microsoft.com/office/drawing/2014/main" id="{76555CF9-FEFA-4434-84EA-D4F5EFD471F5}"/>
+                <a16:creationId xmlns:a16="http://schemas.microsoft.com/office/drawing/2014/main" id="{35B349D3-2D2D-43BB-8003-310CC158B2F5}"/>
               </a:ext>
             </a:extLst>
           </p:cNvPr>
@@ -4151,7 +4151,7 @@
           <p:cNvPr id="13" name="">
             <a:extLst xmlns:a="http://schemas.openxmlformats.org/drawingml/2006/main">
               <a:ext uri="{FF2B5EF4-FFF2-40B4-BE49-F238E27FC236}">
-                <a16:creationId xmlns:a16="http://schemas.microsoft.com/office/drawing/2014/main" id="{42AF42FB-92CB-4B90-8378-3818A4A0BACB}"/>
+                <a16:creationId xmlns:a16="http://schemas.microsoft.com/office/drawing/2014/main" id="{C578446D-1494-4206-ABDC-C38F2492F819}"/>
               </a:ext>
             </a:extLst>
           </p:cNvPr>
@@ -4211,7 +4211,7 @@
           <p:cNvPr id="14" name="">
             <a:extLst xmlns:a="http://schemas.openxmlformats.org/drawingml/2006/main">
               <a:ext uri="{FF2B5EF4-FFF2-40B4-BE49-F238E27FC236}">
-                <a16:creationId xmlns:a16="http://schemas.microsoft.com/office/drawing/2014/main" id="{7D3C4B50-D799-4ABD-9ADC-674676425794}"/>
+                <a16:creationId xmlns:a16="http://schemas.microsoft.com/office/drawing/2014/main" id="{62B0010F-F0A4-49D0-828C-84965FF91BA6}"/>
               </a:ext>
             </a:extLst>
           </p:cNvPr>
@@ -4271,7 +4271,7 @@
           <p:cNvPr id="15" name="">
             <a:extLst xmlns:a="http://schemas.openxmlformats.org/drawingml/2006/main">
               <a:ext uri="{FF2B5EF4-FFF2-40B4-BE49-F238E27FC236}">
-                <a16:creationId xmlns:a16="http://schemas.microsoft.com/office/drawing/2014/main" id="{8155E2F0-D343-4C92-B38A-E89CC9D554C0}"/>
+                <a16:creationId xmlns:a16="http://schemas.microsoft.com/office/drawing/2014/main" id="{87A06D5A-E611-4436-B174-5A8AFA51B8D3}"/>
               </a:ext>
             </a:extLst>
           </p:cNvPr>
@@ -4331,7 +4331,7 @@
           <p:cNvPr id="16" name="">
             <a:extLst xmlns:a="http://schemas.openxmlformats.org/drawingml/2006/main">
               <a:ext uri="{FF2B5EF4-FFF2-40B4-BE49-F238E27FC236}">
-                <a16:creationId xmlns:a16="http://schemas.microsoft.com/office/drawing/2014/main" id="{84108F90-7FF3-4F02-8557-F6935A16F526}"/>
+                <a16:creationId xmlns:a16="http://schemas.microsoft.com/office/drawing/2014/main" id="{EA1EE97E-7D5C-4954-9D1F-EB86A87C4935}"/>
               </a:ext>
             </a:extLst>
           </p:cNvPr>
@@ -4364,7 +4364,7 @@
           <p:cNvPr id="17" name="">
             <a:extLst xmlns:a="http://schemas.openxmlformats.org/drawingml/2006/main">
               <a:ext uri="{FF2B5EF4-FFF2-40B4-BE49-F238E27FC236}">
-                <a16:creationId xmlns:a16="http://schemas.microsoft.com/office/drawing/2014/main" id="{B2DCE018-E753-4CAB-BA83-EF2A132C27C2}"/>
+                <a16:creationId xmlns:a16="http://schemas.microsoft.com/office/drawing/2014/main" id="{233E9F3F-3440-4760-8D96-6BDAB147DB1C}"/>
               </a:ext>
             </a:extLst>
           </p:cNvPr>
@@ -4424,7 +4424,7 @@
           <p:cNvPr id="18" name="">
             <a:extLst xmlns:a="http://schemas.openxmlformats.org/drawingml/2006/main">
               <a:ext uri="{FF2B5EF4-FFF2-40B4-BE49-F238E27FC236}">
-                <a16:creationId xmlns:a16="http://schemas.microsoft.com/office/drawing/2014/main" id="{9D2ABFFC-1F12-45AC-B267-49FC5F1F75AE}"/>
+                <a16:creationId xmlns:a16="http://schemas.microsoft.com/office/drawing/2014/main" id="{3685296A-0CC6-44EB-9BC8-644F53DCBD1E}"/>
               </a:ext>
             </a:extLst>
           </p:cNvPr>
@@ -4484,7 +4484,7 @@
           <p:cNvPr id="19" name="">
             <a:extLst xmlns:a="http://schemas.openxmlformats.org/drawingml/2006/main">
               <a:ext uri="{FF2B5EF4-FFF2-40B4-BE49-F238E27FC236}">
-                <a16:creationId xmlns:a16="http://schemas.microsoft.com/office/drawing/2014/main" id="{A1F43A40-3597-44B5-9667-7E589220E157}"/>
+                <a16:creationId xmlns:a16="http://schemas.microsoft.com/office/drawing/2014/main" id="{41126D07-53C5-46DA-97FF-F0489F517203}"/>
               </a:ext>
             </a:extLst>
           </p:cNvPr>
@@ -4544,7 +4544,7 @@
           <p:cNvPr id="20" name="">
             <a:extLst xmlns:a="http://schemas.openxmlformats.org/drawingml/2006/main">
               <a:ext uri="{FF2B5EF4-FFF2-40B4-BE49-F238E27FC236}">
-                <a16:creationId xmlns:a16="http://schemas.microsoft.com/office/drawing/2014/main" id="{EF1772E6-3FD4-4DC0-9FF2-91BD1B9ABA18}"/>
+                <a16:creationId xmlns:a16="http://schemas.microsoft.com/office/drawing/2014/main" id="{21C645A3-BB41-4514-8774-78FB3D194EF0}"/>
               </a:ext>
             </a:extLst>
           </p:cNvPr>
@@ -4577,7 +4577,7 @@
           <p:cNvPr id="21" name="">
             <a:extLst xmlns:a="http://schemas.openxmlformats.org/drawingml/2006/main">
               <a:ext uri="{FF2B5EF4-FFF2-40B4-BE49-F238E27FC236}">
-                <a16:creationId xmlns:a16="http://schemas.microsoft.com/office/drawing/2014/main" id="{673D59C1-E239-4CDD-AC41-E5551E934DEC}"/>
+                <a16:creationId xmlns:a16="http://schemas.microsoft.com/office/drawing/2014/main" id="{A45971F3-57D5-4EF2-A162-809C86644E9D}"/>
               </a:ext>
             </a:extLst>
           </p:cNvPr>
@@ -4637,7 +4637,7 @@
           <p:cNvPr id="22" name="">
             <a:extLst xmlns:a="http://schemas.openxmlformats.org/drawingml/2006/main">
               <a:ext uri="{FF2B5EF4-FFF2-40B4-BE49-F238E27FC236}">
-                <a16:creationId xmlns:a16="http://schemas.microsoft.com/office/drawing/2014/main" id="{4AFD1007-9076-4595-A93C-829AEA86C339}"/>
+                <a16:creationId xmlns:a16="http://schemas.microsoft.com/office/drawing/2014/main" id="{2CA8F82C-2B83-48DE-BAFA-2A41B245C9B3}"/>
               </a:ext>
             </a:extLst>
           </p:cNvPr>
@@ -4697,7 +4697,7 @@
           <p:cNvPr id="23" name="">
             <a:extLst xmlns:a="http://schemas.openxmlformats.org/drawingml/2006/main">
               <a:ext uri="{FF2B5EF4-FFF2-40B4-BE49-F238E27FC236}">
-                <a16:creationId xmlns:a16="http://schemas.microsoft.com/office/drawing/2014/main" id="{3B9AA1F4-3B6C-4DDB-948D-9560BD6089DF}"/>
+                <a16:creationId xmlns:a16="http://schemas.microsoft.com/office/drawing/2014/main" id="{7476AF0A-B854-4E96-BEE3-1AF53514F03E}"/>
               </a:ext>
             </a:extLst>
           </p:cNvPr>
@@ -4757,7 +4757,7 @@
           <p:cNvPr id="24" name="">
             <a:extLst xmlns:a="http://schemas.openxmlformats.org/drawingml/2006/main">
               <a:ext uri="{FF2B5EF4-FFF2-40B4-BE49-F238E27FC236}">
-                <a16:creationId xmlns:a16="http://schemas.microsoft.com/office/drawing/2014/main" id="{E509570A-003C-49E6-8940-7559D0BE59D7}"/>
+                <a16:creationId xmlns:a16="http://schemas.microsoft.com/office/drawing/2014/main" id="{A20B7BE7-084E-438D-ABCC-38C284D95414}"/>
               </a:ext>
             </a:extLst>
           </p:cNvPr>
@@ -4790,7 +4790,7 @@
           <p:cNvPr id="25" name="">
             <a:extLst xmlns:a="http://schemas.openxmlformats.org/drawingml/2006/main">
               <a:ext uri="{FF2B5EF4-FFF2-40B4-BE49-F238E27FC236}">
-                <a16:creationId xmlns:a16="http://schemas.microsoft.com/office/drawing/2014/main" id="{74516BFB-ABA7-41C3-A654-C5AFE6F7950C}"/>
+                <a16:creationId xmlns:a16="http://schemas.microsoft.com/office/drawing/2014/main" id="{40F77BD4-6D38-445D-97E6-42CE4D1FADEA}"/>
               </a:ext>
             </a:extLst>
           </p:cNvPr>
@@ -4850,7 +4850,7 @@
           <p:cNvPr id="26" name="">
             <a:extLst xmlns:a="http://schemas.openxmlformats.org/drawingml/2006/main">
               <a:ext uri="{FF2B5EF4-FFF2-40B4-BE49-F238E27FC236}">
-                <a16:creationId xmlns:a16="http://schemas.microsoft.com/office/drawing/2014/main" id="{FF00CF08-17B5-47BE-8AAD-5F6F99BE44A8}"/>
+                <a16:creationId xmlns:a16="http://schemas.microsoft.com/office/drawing/2014/main" id="{2E422175-20E5-4407-8CBB-64BFED5628CA}"/>
               </a:ext>
             </a:extLst>
           </p:cNvPr>
@@ -4910,7 +4910,7 @@
           <p:cNvPr id="27" name="">
             <a:extLst xmlns:a="http://schemas.openxmlformats.org/drawingml/2006/main">
               <a:ext uri="{FF2B5EF4-FFF2-40B4-BE49-F238E27FC236}">
-                <a16:creationId xmlns:a16="http://schemas.microsoft.com/office/drawing/2014/main" id="{9900DBEB-8DB5-441E-839B-E9B6D2AD2633}"/>
+                <a16:creationId xmlns:a16="http://schemas.microsoft.com/office/drawing/2014/main" id="{5DC1F981-D8AA-4563-B3F0-BCD742B19C0A}"/>
               </a:ext>
             </a:extLst>
           </p:cNvPr>
@@ -4970,7 +4970,7 @@
           <p:cNvPr id="28" name="">
             <a:extLst xmlns:a="http://schemas.openxmlformats.org/drawingml/2006/main">
               <a:ext uri="{FF2B5EF4-FFF2-40B4-BE49-F238E27FC236}">
-                <a16:creationId xmlns:a16="http://schemas.microsoft.com/office/drawing/2014/main" id="{263B20CC-C0ED-4F37-B879-F4971286D3B5}"/>
+                <a16:creationId xmlns:a16="http://schemas.microsoft.com/office/drawing/2014/main" id="{1C7AF4A0-C5A6-4C22-BF13-0117F2F9C432}"/>
               </a:ext>
             </a:extLst>
           </p:cNvPr>
@@ -5028,7 +5028,7 @@
     </p:spTree>
     <p:extLst>
       <p:ext uri="{BB962C8B-B14F-4D97-AF65-F5344CB8AC3E}">
-        <p14:creationId xmlns:p14="http://schemas.microsoft.com/office/powerpoint/2010/main" val="1952625308"/>
+        <p14:creationId xmlns:p14="http://schemas.microsoft.com/office/powerpoint/2010/main" val="1590201617"/>
       </p:ext>
     </p:extLst>
   </p:cSld>
@@ -5052,7 +5052,7 @@
           <p:cNvPr id="1" name="">
             <a:extLst xmlns:a="http://schemas.openxmlformats.org/drawingml/2006/main">
               <a:ext uri="{FF2B5EF4-FFF2-40B4-BE49-F238E27FC236}">
-                <a16:creationId xmlns:a16="http://schemas.microsoft.com/office/drawing/2014/main" id="{FA071DB0-46AE-4803-9855-0BA71F4B826E}"/>
+                <a16:creationId xmlns:a16="http://schemas.microsoft.com/office/drawing/2014/main" id="{6A05D72A-998F-4681-9A6E-B342EFEF0BDF}"/>
               </a:ext>
             </a:extLst>
           </p:cNvPr>
@@ -5112,7 +5112,7 @@
           <p:cNvPr id="2" name="">
             <a:extLst xmlns:a="http://schemas.openxmlformats.org/drawingml/2006/main">
               <a:ext uri="{FF2B5EF4-FFF2-40B4-BE49-F238E27FC236}">
-                <a16:creationId xmlns:a16="http://schemas.microsoft.com/office/drawing/2014/main" id="{99FF169D-F743-4923-A164-AA3CD2CAE369}"/>
+                <a16:creationId xmlns:a16="http://schemas.microsoft.com/office/drawing/2014/main" id="{2C9AB145-654C-4B3D-9AB4-96E489060A7E}"/>
               </a:ext>
             </a:extLst>
           </p:cNvPr>
@@ -5172,7 +5172,7 @@
           <p:cNvPr id="3" name="">
             <a:extLst xmlns:a="http://schemas.openxmlformats.org/drawingml/2006/main">
               <a:ext uri="{FF2B5EF4-FFF2-40B4-BE49-F238E27FC236}">
-                <a16:creationId xmlns:a16="http://schemas.microsoft.com/office/drawing/2014/main" id="{8C7CAC1C-D92B-446A-9240-9A0F5A3A76AB}"/>
+                <a16:creationId xmlns:a16="http://schemas.microsoft.com/office/drawing/2014/main" id="{ECCDFA85-2F44-4263-8F43-66A8E29D14FC}"/>
               </a:ext>
             </a:extLst>
           </p:cNvPr>
@@ -5205,7 +5205,7 @@
           <p:cNvPr id="4" name="">
             <a:extLst xmlns:a="http://schemas.openxmlformats.org/drawingml/2006/main">
               <a:ext uri="{FF2B5EF4-FFF2-40B4-BE49-F238E27FC236}">
-                <a16:creationId xmlns:a16="http://schemas.microsoft.com/office/drawing/2014/main" id="{7A38D7DF-C5FD-4EAE-B0CC-BAA4BB3286B3}"/>
+                <a16:creationId xmlns:a16="http://schemas.microsoft.com/office/drawing/2014/main" id="{E78AFB72-55B0-45A9-AA97-632899C3BA77}"/>
               </a:ext>
             </a:extLst>
           </p:cNvPr>
@@ -5238,7 +5238,7 @@
           <p:cNvPr id="5" name="">
             <a:extLst xmlns:a="http://schemas.openxmlformats.org/drawingml/2006/main">
               <a:ext uri="{FF2B5EF4-FFF2-40B4-BE49-F238E27FC236}">
-                <a16:creationId xmlns:a16="http://schemas.microsoft.com/office/drawing/2014/main" id="{20608FE1-14DC-43CC-9C61-8860870618A4}"/>
+                <a16:creationId xmlns:a16="http://schemas.microsoft.com/office/drawing/2014/main" id="{6D3A8450-ADB2-4026-9071-28D4EDAD66A2}"/>
               </a:ext>
             </a:extLst>
           </p:cNvPr>
@@ -5298,7 +5298,7 @@
           <p:cNvPr id="6" name="">
             <a:extLst xmlns:a="http://schemas.openxmlformats.org/drawingml/2006/main">
               <a:ext uri="{FF2B5EF4-FFF2-40B4-BE49-F238E27FC236}">
-                <a16:creationId xmlns:a16="http://schemas.microsoft.com/office/drawing/2014/main" id="{91998844-C255-47AE-9F56-DB47B60CBEB8}"/>
+                <a16:creationId xmlns:a16="http://schemas.microsoft.com/office/drawing/2014/main" id="{61BB0ED4-D11E-4153-9F3D-556A6B1C68CD}"/>
               </a:ext>
             </a:extLst>
           </p:cNvPr>
@@ -5331,7 +5331,7 @@
           <p:cNvPr id="7" name="">
             <a:extLst xmlns:a="http://schemas.openxmlformats.org/drawingml/2006/main">
               <a:ext uri="{FF2B5EF4-FFF2-40B4-BE49-F238E27FC236}">
-                <a16:creationId xmlns:a16="http://schemas.microsoft.com/office/drawing/2014/main" id="{04145BBE-1E40-4242-9D59-4337132FC649}"/>
+                <a16:creationId xmlns:a16="http://schemas.microsoft.com/office/drawing/2014/main" id="{E300FC6A-B390-4092-B694-3565CE69B151}"/>
               </a:ext>
             </a:extLst>
           </p:cNvPr>
@@ -5364,7 +5364,7 @@
           <p:cNvPr id="8" name="">
             <a:extLst xmlns:a="http://schemas.openxmlformats.org/drawingml/2006/main">
               <a:ext uri="{FF2B5EF4-FFF2-40B4-BE49-F238E27FC236}">
-                <a16:creationId xmlns:a16="http://schemas.microsoft.com/office/drawing/2014/main" id="{B9DD79D7-AE91-4381-A618-8CC0FDB88FEC}"/>
+                <a16:creationId xmlns:a16="http://schemas.microsoft.com/office/drawing/2014/main" id="{F03E5FB9-C4DB-4D52-A219-852EEDEC6E6C}"/>
               </a:ext>
             </a:extLst>
           </p:cNvPr>
@@ -5424,7 +5424,7 @@
           <p:cNvPr id="9" name="">
             <a:extLst xmlns:a="http://schemas.openxmlformats.org/drawingml/2006/main">
               <a:ext uri="{FF2B5EF4-FFF2-40B4-BE49-F238E27FC236}">
-                <a16:creationId xmlns:a16="http://schemas.microsoft.com/office/drawing/2014/main" id="{67D6D8D4-A184-4C4A-AB55-2448BDC55FDC}"/>
+                <a16:creationId xmlns:a16="http://schemas.microsoft.com/office/drawing/2014/main" id="{E79AF180-649A-47F0-B523-35FD119015CB}"/>
               </a:ext>
             </a:extLst>
           </p:cNvPr>
@@ -5457,7 +5457,7 @@
           <p:cNvPr id="10" name="">
             <a:extLst xmlns:a="http://schemas.openxmlformats.org/drawingml/2006/main">
               <a:ext uri="{FF2B5EF4-FFF2-40B4-BE49-F238E27FC236}">
-                <a16:creationId xmlns:a16="http://schemas.microsoft.com/office/drawing/2014/main" id="{BEBE0303-EB2F-4F2A-AD3E-3807002F8E05}"/>
+                <a16:creationId xmlns:a16="http://schemas.microsoft.com/office/drawing/2014/main" id="{00C30962-5F61-48FA-946D-971004BE5F43}"/>
               </a:ext>
             </a:extLst>
           </p:cNvPr>
@@ -5490,7 +5490,7 @@
           <p:cNvPr id="11" name="">
             <a:extLst xmlns:a="http://schemas.openxmlformats.org/drawingml/2006/main">
               <a:ext uri="{FF2B5EF4-FFF2-40B4-BE49-F238E27FC236}">
-                <a16:creationId xmlns:a16="http://schemas.microsoft.com/office/drawing/2014/main" id="{41AE7313-BDC3-4E3D-9FD3-98108CA6EE1C}"/>
+                <a16:creationId xmlns:a16="http://schemas.microsoft.com/office/drawing/2014/main" id="{520AD05C-4409-44D7-8356-9BB97FBA58D7}"/>
               </a:ext>
             </a:extLst>
           </p:cNvPr>
@@ -5550,7 +5550,7 @@
           <p:cNvPr id="12" name="">
             <a:extLst xmlns:a="http://schemas.openxmlformats.org/drawingml/2006/main">
               <a:ext uri="{FF2B5EF4-FFF2-40B4-BE49-F238E27FC236}">
-                <a16:creationId xmlns:a16="http://schemas.microsoft.com/office/drawing/2014/main" id="{D6DB227C-CD54-4040-8825-2A570C6089C5}"/>
+                <a16:creationId xmlns:a16="http://schemas.microsoft.com/office/drawing/2014/main" id="{1580EA6F-4EBE-4716-A426-C3DB7C552204}"/>
               </a:ext>
             </a:extLst>
           </p:cNvPr>
@@ -5583,7 +5583,7 @@
           <p:cNvPr id="13" name="">
             <a:extLst xmlns:a="http://schemas.openxmlformats.org/drawingml/2006/main">
               <a:ext uri="{FF2B5EF4-FFF2-40B4-BE49-F238E27FC236}">
-                <a16:creationId xmlns:a16="http://schemas.microsoft.com/office/drawing/2014/main" id="{6FBE8396-E425-46E5-B7EE-D4EDBCCB6FA2}"/>
+                <a16:creationId xmlns:a16="http://schemas.microsoft.com/office/drawing/2014/main" id="{69FAEB67-3702-4929-BE47-EAB04C6AC5B6}"/>
               </a:ext>
             </a:extLst>
           </p:cNvPr>
@@ -5616,7 +5616,7 @@
           <p:cNvPr id="14" name="">
             <a:extLst xmlns:a="http://schemas.openxmlformats.org/drawingml/2006/main">
               <a:ext uri="{FF2B5EF4-FFF2-40B4-BE49-F238E27FC236}">
-                <a16:creationId xmlns:a16="http://schemas.microsoft.com/office/drawing/2014/main" id="{5AAED8FC-4CA1-4FBD-945A-FCBD06A1B057}"/>
+                <a16:creationId xmlns:a16="http://schemas.microsoft.com/office/drawing/2014/main" id="{6D080926-D96A-4181-86B9-B1EC861ACF2C}"/>
               </a:ext>
             </a:extLst>
           </p:cNvPr>
@@ -5676,7 +5676,7 @@
           <p:cNvPr id="15" name="">
             <a:extLst xmlns:a="http://schemas.openxmlformats.org/drawingml/2006/main">
               <a:ext uri="{FF2B5EF4-FFF2-40B4-BE49-F238E27FC236}">
-                <a16:creationId xmlns:a16="http://schemas.microsoft.com/office/drawing/2014/main" id="{1FD028C2-54EC-493C-9A82-CED6093555A0}"/>
+                <a16:creationId xmlns:a16="http://schemas.microsoft.com/office/drawing/2014/main" id="{24AF0091-386C-491F-A373-06012C7C1CB6}"/>
               </a:ext>
             </a:extLst>
           </p:cNvPr>
@@ -5709,7 +5709,7 @@
           <p:cNvPr id="16" name="">
             <a:extLst xmlns:a="http://schemas.openxmlformats.org/drawingml/2006/main">
               <a:ext uri="{FF2B5EF4-FFF2-40B4-BE49-F238E27FC236}">
-                <a16:creationId xmlns:a16="http://schemas.microsoft.com/office/drawing/2014/main" id="{57F0D159-50D7-41B9-BCA5-0114413005DF}"/>
+                <a16:creationId xmlns:a16="http://schemas.microsoft.com/office/drawing/2014/main" id="{266D2289-1655-4D92-9A11-82F222C3DF65}"/>
               </a:ext>
             </a:extLst>
           </p:cNvPr>
@@ -5742,7 +5742,7 @@
           <p:cNvPr id="17" name="">
             <a:extLst xmlns:a="http://schemas.openxmlformats.org/drawingml/2006/main">
               <a:ext uri="{FF2B5EF4-FFF2-40B4-BE49-F238E27FC236}">
-                <a16:creationId xmlns:a16="http://schemas.microsoft.com/office/drawing/2014/main" id="{3BA9084E-2C90-4D17-8B6B-1600232665D7}"/>
+                <a16:creationId xmlns:a16="http://schemas.microsoft.com/office/drawing/2014/main" id="{6C1DEA65-75EF-421A-A487-95BCB40829B4}"/>
               </a:ext>
             </a:extLst>
           </p:cNvPr>
@@ -5802,7 +5802,7 @@
           <p:cNvPr id="18" name="">
             <a:extLst xmlns:a="http://schemas.openxmlformats.org/drawingml/2006/main">
               <a:ext uri="{FF2B5EF4-FFF2-40B4-BE49-F238E27FC236}">
-                <a16:creationId xmlns:a16="http://schemas.microsoft.com/office/drawing/2014/main" id="{E36A04EF-71B8-473C-819C-064A393EB4F9}"/>
+                <a16:creationId xmlns:a16="http://schemas.microsoft.com/office/drawing/2014/main" id="{CDDF7142-6E6D-438F-8103-A1A19F46E2F2}"/>
               </a:ext>
             </a:extLst>
           </p:cNvPr>
@@ -5834,7 +5834,7 @@
           <a:lstStyle xmlns:a="http://schemas.openxmlformats.org/drawingml/2006/main"/>
           <a:p xmlns:a="http://schemas.openxmlformats.org/drawingml/2006/main">
             <a:pPr algn="ctr">
-              <a:defRPr sz="1650" b="0">
+              <a:defRPr sz="1500" b="0">
                 <a:solidFill>
                   <a:srgbClr val="1D2939"/>
                 </a:solidFill>
@@ -5844,7 +5844,7 @@
               </a:defRPr>
             </a:pPr>
             <a:r>
-              <a:rPr sz="1650" b="0">
+              <a:rPr sz="1500" b="0">
                 <a:solidFill>
                   <a:srgbClr val="1D2939"/>
                 </a:solidFill>
@@ -5852,7 +5852,7 @@
                 <a:ea typeface="Aptos"/>
                 <a:cs typeface="Aptos"/>
               </a:rPr>
-              <a:t>Implemented: BM25, dense MiniLM, hybrid retrieval, pretrained reranker evaluation, embedding/reranker training scripts, QA metrics.</a:t>
+              <a:t>Implemented: BM25, dense MiniLM, hybrid retrieval, embedding fine-tuning, reranker fine-tuning, LLM/SFT smoke training, QA metrics, and judge-based faithfulness.</a:t>
             </a:r>
           </a:p>
         </p:txBody>
@@ -5862,7 +5862,7 @@
           <p:cNvPr id="19" name="">
             <a:extLst xmlns:a="http://schemas.openxmlformats.org/drawingml/2006/main">
               <a:ext uri="{FF2B5EF4-FFF2-40B4-BE49-F238E27FC236}">
-                <a16:creationId xmlns:a16="http://schemas.microsoft.com/office/drawing/2014/main" id="{99C06939-FF95-417B-A5EF-DAF044E6E12A}"/>
+                <a16:creationId xmlns:a16="http://schemas.microsoft.com/office/drawing/2014/main" id="{4AFE50C8-1DAE-4561-A8DA-1E687B96840F}"/>
               </a:ext>
             </a:extLst>
           </p:cNvPr>
@@ -5920,7 +5920,7 @@
     </p:spTree>
     <p:extLst>
       <p:ext uri="{BB962C8B-B14F-4D97-AF65-F5344CB8AC3E}">
-        <p14:creationId xmlns:p14="http://schemas.microsoft.com/office/powerpoint/2010/main" val="1494577983"/>
+        <p14:creationId xmlns:p14="http://schemas.microsoft.com/office/powerpoint/2010/main" val="1286898181"/>
       </p:ext>
     </p:extLst>
   </p:cSld>
@@ -5944,7 +5944,7 @@
           <p:cNvPr id="1" name="">
             <a:extLst xmlns:a="http://schemas.openxmlformats.org/drawingml/2006/main">
               <a:ext uri="{FF2B5EF4-FFF2-40B4-BE49-F238E27FC236}">
-                <a16:creationId xmlns:a16="http://schemas.microsoft.com/office/drawing/2014/main" id="{DF092ED0-D058-4E73-8746-241F164ADBE0}"/>
+                <a16:creationId xmlns:a16="http://schemas.microsoft.com/office/drawing/2014/main" id="{AB2067BF-5630-4D15-AE84-FF22E8137E0B}"/>
               </a:ext>
             </a:extLst>
           </p:cNvPr>
@@ -6004,7 +6004,7 @@
           <p:cNvPr id="2" name="">
             <a:extLst xmlns:a="http://schemas.openxmlformats.org/drawingml/2006/main">
               <a:ext uri="{FF2B5EF4-FFF2-40B4-BE49-F238E27FC236}">
-                <a16:creationId xmlns:a16="http://schemas.microsoft.com/office/drawing/2014/main" id="{381210D8-FBA5-4F43-B934-1A3D4641FD79}"/>
+                <a16:creationId xmlns:a16="http://schemas.microsoft.com/office/drawing/2014/main" id="{04A103AF-219A-4422-B45F-E92959BAB946}"/>
               </a:ext>
             </a:extLst>
           </p:cNvPr>
@@ -6064,7 +6064,7 @@
           <p:cNvPr id="3" name="">
             <a:extLst xmlns:a="http://schemas.openxmlformats.org/drawingml/2006/main">
               <a:ext uri="{FF2B5EF4-FFF2-40B4-BE49-F238E27FC236}">
-                <a16:creationId xmlns:a16="http://schemas.microsoft.com/office/drawing/2014/main" id="{E4445DA3-CF3A-4863-8ED1-855950897EA1}"/>
+                <a16:creationId xmlns:a16="http://schemas.microsoft.com/office/drawing/2014/main" id="{BF240F7B-5779-4871-B60A-A438D0AB711D}"/>
               </a:ext>
             </a:extLst>
           </p:cNvPr>
@@ -6097,7 +6097,7 @@
           <p:cNvPr id="4" name="">
             <a:extLst xmlns:a="http://schemas.openxmlformats.org/drawingml/2006/main">
               <a:ext uri="{FF2B5EF4-FFF2-40B4-BE49-F238E27FC236}">
-                <a16:creationId xmlns:a16="http://schemas.microsoft.com/office/drawing/2014/main" id="{14CBB8BD-10B2-4C20-8B1F-65C659004B5D}"/>
+                <a16:creationId xmlns:a16="http://schemas.microsoft.com/office/drawing/2014/main" id="{027A1EF7-24E0-4C18-8F2E-0B794FD560DC}"/>
               </a:ext>
             </a:extLst>
           </p:cNvPr>
@@ -6157,7 +6157,7 @@
           <p:cNvPr id="5" name="">
             <a:extLst xmlns:a="http://schemas.openxmlformats.org/drawingml/2006/main">
               <a:ext uri="{FF2B5EF4-FFF2-40B4-BE49-F238E27FC236}">
-                <a16:creationId xmlns:a16="http://schemas.microsoft.com/office/drawing/2014/main" id="{1FEE4921-E24E-477B-B8B5-F2FB994EABDA}"/>
+                <a16:creationId xmlns:a16="http://schemas.microsoft.com/office/drawing/2014/main" id="{EA3EEE7E-CD50-4FB4-B5DF-2FE1EA65D8F6}"/>
               </a:ext>
             </a:extLst>
           </p:cNvPr>
@@ -6190,7 +6190,7 @@
           <p:cNvPr id="6" name="">
             <a:extLst xmlns:a="http://schemas.openxmlformats.org/drawingml/2006/main">
               <a:ext uri="{FF2B5EF4-FFF2-40B4-BE49-F238E27FC236}">
-                <a16:creationId xmlns:a16="http://schemas.microsoft.com/office/drawing/2014/main" id="{10B2457D-81FF-472E-B683-0763F14753F3}"/>
+                <a16:creationId xmlns:a16="http://schemas.microsoft.com/office/drawing/2014/main" id="{7B935EA6-A906-4762-938C-D68748EFC38E}"/>
               </a:ext>
             </a:extLst>
           </p:cNvPr>
@@ -6223,7 +6223,7 @@
           <p:cNvPr id="7" name="">
             <a:extLst xmlns:a="http://schemas.openxmlformats.org/drawingml/2006/main">
               <a:ext uri="{FF2B5EF4-FFF2-40B4-BE49-F238E27FC236}">
-                <a16:creationId xmlns:a16="http://schemas.microsoft.com/office/drawing/2014/main" id="{02DD77AB-7B97-42B7-A2C6-7A6F7F3DCD29}"/>
+                <a16:creationId xmlns:a16="http://schemas.microsoft.com/office/drawing/2014/main" id="{3DF231D4-ECB0-4659-B132-B5A1AA931F11}"/>
               </a:ext>
             </a:extLst>
           </p:cNvPr>
@@ -6283,7 +6283,7 @@
           <p:cNvPr id="8" name="">
             <a:extLst xmlns:a="http://schemas.openxmlformats.org/drawingml/2006/main">
               <a:ext uri="{FF2B5EF4-FFF2-40B4-BE49-F238E27FC236}">
-                <a16:creationId xmlns:a16="http://schemas.microsoft.com/office/drawing/2014/main" id="{FB685025-CC42-4ECD-A468-11D3AF20C6AB}"/>
+                <a16:creationId xmlns:a16="http://schemas.microsoft.com/office/drawing/2014/main" id="{4AE1B42D-DA2D-4D03-B91F-161D98816FA8}"/>
               </a:ext>
             </a:extLst>
           </p:cNvPr>
@@ -6343,7 +6343,7 @@
           <p:cNvPr id="9" name="">
             <a:extLst xmlns:a="http://schemas.openxmlformats.org/drawingml/2006/main">
               <a:ext uri="{FF2B5EF4-FFF2-40B4-BE49-F238E27FC236}">
-                <a16:creationId xmlns:a16="http://schemas.microsoft.com/office/drawing/2014/main" id="{B09E5D66-DB9F-4F93-B507-7C7A63979B22}"/>
+                <a16:creationId xmlns:a16="http://schemas.microsoft.com/office/drawing/2014/main" id="{472AA8B3-0797-4FBE-985F-8DD50665607E}"/>
               </a:ext>
             </a:extLst>
           </p:cNvPr>
@@ -6376,7 +6376,7 @@
           <p:cNvPr id="10" name="">
             <a:extLst xmlns:a="http://schemas.openxmlformats.org/drawingml/2006/main">
               <a:ext uri="{FF2B5EF4-FFF2-40B4-BE49-F238E27FC236}">
-                <a16:creationId xmlns:a16="http://schemas.microsoft.com/office/drawing/2014/main" id="{16126A09-A367-4AE6-BFE5-B59B4C64A4C3}"/>
+                <a16:creationId xmlns:a16="http://schemas.microsoft.com/office/drawing/2014/main" id="{CD132511-3D94-4A1A-A055-B921DABBB19B}"/>
               </a:ext>
             </a:extLst>
           </p:cNvPr>
@@ -6409,7 +6409,7 @@
           <p:cNvPr id="11" name="">
             <a:extLst xmlns:a="http://schemas.openxmlformats.org/drawingml/2006/main">
               <a:ext uri="{FF2B5EF4-FFF2-40B4-BE49-F238E27FC236}">
-                <a16:creationId xmlns:a16="http://schemas.microsoft.com/office/drawing/2014/main" id="{8C0AA3D5-4474-440B-BF25-312AB5568909}"/>
+                <a16:creationId xmlns:a16="http://schemas.microsoft.com/office/drawing/2014/main" id="{14C18535-10F0-4725-9A93-FFC1E0AE7007}"/>
               </a:ext>
             </a:extLst>
           </p:cNvPr>
@@ -6469,7 +6469,7 @@
           <p:cNvPr id="12" name="">
             <a:extLst xmlns:a="http://schemas.openxmlformats.org/drawingml/2006/main">
               <a:ext uri="{FF2B5EF4-FFF2-40B4-BE49-F238E27FC236}">
-                <a16:creationId xmlns:a16="http://schemas.microsoft.com/office/drawing/2014/main" id="{E3EC773B-089D-4F85-ADD1-C9E4E07A85D0}"/>
+                <a16:creationId xmlns:a16="http://schemas.microsoft.com/office/drawing/2014/main" id="{14F9D9E7-10BE-4530-8C16-AE18C635C918}"/>
               </a:ext>
             </a:extLst>
           </p:cNvPr>
@@ -6529,7 +6529,7 @@
           <p:cNvPr id="13" name="">
             <a:extLst xmlns:a="http://schemas.openxmlformats.org/drawingml/2006/main">
               <a:ext uri="{FF2B5EF4-FFF2-40B4-BE49-F238E27FC236}">
-                <a16:creationId xmlns:a16="http://schemas.microsoft.com/office/drawing/2014/main" id="{41D17E75-A0CE-4AD6-B3A8-F3B0AE1DFD1C}"/>
+                <a16:creationId xmlns:a16="http://schemas.microsoft.com/office/drawing/2014/main" id="{EE1EBA31-6303-41B7-915F-D6882C451FB2}"/>
               </a:ext>
             </a:extLst>
           </p:cNvPr>
@@ -6562,7 +6562,7 @@
           <p:cNvPr id="14" name="">
             <a:extLst xmlns:a="http://schemas.openxmlformats.org/drawingml/2006/main">
               <a:ext uri="{FF2B5EF4-FFF2-40B4-BE49-F238E27FC236}">
-                <a16:creationId xmlns:a16="http://schemas.microsoft.com/office/drawing/2014/main" id="{A1822E6A-24B2-4ABE-99BA-F5DB9CA08ED8}"/>
+                <a16:creationId xmlns:a16="http://schemas.microsoft.com/office/drawing/2014/main" id="{03465CCC-8BAB-4048-9D5A-0E09694E677D}"/>
               </a:ext>
             </a:extLst>
           </p:cNvPr>
@@ -6595,7 +6595,7 @@
           <p:cNvPr id="15" name="">
             <a:extLst xmlns:a="http://schemas.openxmlformats.org/drawingml/2006/main">
               <a:ext uri="{FF2B5EF4-FFF2-40B4-BE49-F238E27FC236}">
-                <a16:creationId xmlns:a16="http://schemas.microsoft.com/office/drawing/2014/main" id="{56338D8E-057E-40AD-AC02-F1C4F38E85C5}"/>
+                <a16:creationId xmlns:a16="http://schemas.microsoft.com/office/drawing/2014/main" id="{BA9C12BD-AA61-48DD-A64D-5487397F69AC}"/>
               </a:ext>
             </a:extLst>
           </p:cNvPr>
@@ -6655,7 +6655,7 @@
           <p:cNvPr id="16" name="">
             <a:extLst xmlns:a="http://schemas.openxmlformats.org/drawingml/2006/main">
               <a:ext uri="{FF2B5EF4-FFF2-40B4-BE49-F238E27FC236}">
-                <a16:creationId xmlns:a16="http://schemas.microsoft.com/office/drawing/2014/main" id="{DDDB69C0-154E-44C4-94B9-3CFB46FA95C3}"/>
+                <a16:creationId xmlns:a16="http://schemas.microsoft.com/office/drawing/2014/main" id="{E83C875C-AB57-417F-B83A-2A38ECEE8557}"/>
               </a:ext>
             </a:extLst>
           </p:cNvPr>
@@ -6688,7 +6688,7 @@
           <p:cNvPr id="17" name="">
             <a:extLst xmlns:a="http://schemas.openxmlformats.org/drawingml/2006/main">
               <a:ext uri="{FF2B5EF4-FFF2-40B4-BE49-F238E27FC236}">
-                <a16:creationId xmlns:a16="http://schemas.microsoft.com/office/drawing/2014/main" id="{C405E604-5FA3-4BD3-8F2D-59A436E13846}"/>
+                <a16:creationId xmlns:a16="http://schemas.microsoft.com/office/drawing/2014/main" id="{62095C58-1337-43FE-9991-75F3365B65F4}"/>
               </a:ext>
             </a:extLst>
           </p:cNvPr>
@@ -6748,7 +6748,7 @@
           <p:cNvPr id="18" name="">
             <a:extLst xmlns:a="http://schemas.openxmlformats.org/drawingml/2006/main">
               <a:ext uri="{FF2B5EF4-FFF2-40B4-BE49-F238E27FC236}">
-                <a16:creationId xmlns:a16="http://schemas.microsoft.com/office/drawing/2014/main" id="{6A8BEF15-852C-4861-A999-509BD810CBE6}"/>
+                <a16:creationId xmlns:a16="http://schemas.microsoft.com/office/drawing/2014/main" id="{36B51A43-3056-4B59-A03E-0C0B2874EEAB}"/>
               </a:ext>
             </a:extLst>
           </p:cNvPr>
@@ -6808,7 +6808,7 @@
           <p:cNvPr id="19" name="">
             <a:extLst xmlns:a="http://schemas.openxmlformats.org/drawingml/2006/main">
               <a:ext uri="{FF2B5EF4-FFF2-40B4-BE49-F238E27FC236}">
-                <a16:creationId xmlns:a16="http://schemas.microsoft.com/office/drawing/2014/main" id="{812D89F1-2402-4E95-8CBE-76BA8659EB6C}"/>
+                <a16:creationId xmlns:a16="http://schemas.microsoft.com/office/drawing/2014/main" id="{0B67ABC3-1CCF-43F0-A207-C9D054E5ECEA}"/>
               </a:ext>
             </a:extLst>
           </p:cNvPr>
@@ -6841,7 +6841,7 @@
           <p:cNvPr id="20" name="">
             <a:extLst xmlns:a="http://schemas.openxmlformats.org/drawingml/2006/main">
               <a:ext uri="{FF2B5EF4-FFF2-40B4-BE49-F238E27FC236}">
-                <a16:creationId xmlns:a16="http://schemas.microsoft.com/office/drawing/2014/main" id="{E6C064E7-A444-4D23-B2CA-E2F60130CA9F}"/>
+                <a16:creationId xmlns:a16="http://schemas.microsoft.com/office/drawing/2014/main" id="{18A9DB42-0184-40D9-87B7-BD3461647727}"/>
               </a:ext>
             </a:extLst>
           </p:cNvPr>
@@ -6901,7 +6901,7 @@
           <p:cNvPr id="21" name="">
             <a:extLst xmlns:a="http://schemas.openxmlformats.org/drawingml/2006/main">
               <a:ext uri="{FF2B5EF4-FFF2-40B4-BE49-F238E27FC236}">
-                <a16:creationId xmlns:a16="http://schemas.microsoft.com/office/drawing/2014/main" id="{2B584098-D488-42B4-8BC4-263810FC7F9D}"/>
+                <a16:creationId xmlns:a16="http://schemas.microsoft.com/office/drawing/2014/main" id="{D439658D-F5DC-4444-8901-0804AA13A236}"/>
               </a:ext>
             </a:extLst>
           </p:cNvPr>
@@ -6961,7 +6961,7 @@
           <p:cNvPr id="22" name="">
             <a:extLst xmlns:a="http://schemas.openxmlformats.org/drawingml/2006/main">
               <a:ext uri="{FF2B5EF4-FFF2-40B4-BE49-F238E27FC236}">
-                <a16:creationId xmlns:a16="http://schemas.microsoft.com/office/drawing/2014/main" id="{4E510A80-B70B-42C1-B681-16351043419A}"/>
+                <a16:creationId xmlns:a16="http://schemas.microsoft.com/office/drawing/2014/main" id="{59E57277-8AF7-4521-BEF1-56EE1293C064}"/>
               </a:ext>
             </a:extLst>
           </p:cNvPr>
@@ -7021,7 +7021,7 @@
           <p:cNvPr id="23" name="">
             <a:extLst xmlns:a="http://schemas.openxmlformats.org/drawingml/2006/main">
               <a:ext uri="{FF2B5EF4-FFF2-40B4-BE49-F238E27FC236}">
-                <a16:creationId xmlns:a16="http://schemas.microsoft.com/office/drawing/2014/main" id="{52987C3E-5974-4B14-B04E-EC4FD2319294}"/>
+                <a16:creationId xmlns:a16="http://schemas.microsoft.com/office/drawing/2014/main" id="{512FF88C-A1BE-4A91-8AD2-BFBCAD6D4F7F}"/>
               </a:ext>
             </a:extLst>
           </p:cNvPr>
@@ -7079,7 +7079,7 @@
     </p:spTree>
     <p:extLst>
       <p:ext uri="{BB962C8B-B14F-4D97-AF65-F5344CB8AC3E}">
-        <p14:creationId xmlns:p14="http://schemas.microsoft.com/office/powerpoint/2010/main" val="1338604740"/>
+        <p14:creationId xmlns:p14="http://schemas.microsoft.com/office/powerpoint/2010/main" val="1646589663"/>
       </p:ext>
     </p:extLst>
   </p:cSld>
@@ -7103,7 +7103,7 @@
           <p:cNvPr id="1" name="">
             <a:extLst xmlns:a="http://schemas.openxmlformats.org/drawingml/2006/main">
               <a:ext uri="{FF2B5EF4-FFF2-40B4-BE49-F238E27FC236}">
-                <a16:creationId xmlns:a16="http://schemas.microsoft.com/office/drawing/2014/main" id="{9368E876-CA19-4035-9CF6-5406CF0C7E47}"/>
+                <a16:creationId xmlns:a16="http://schemas.microsoft.com/office/drawing/2014/main" id="{462E800F-D674-4D57-819C-CE84D7ED38BC}"/>
               </a:ext>
             </a:extLst>
           </p:cNvPr>
@@ -7163,7 +7163,7 @@
           <p:cNvPr id="2" name="">
             <a:extLst xmlns:a="http://schemas.openxmlformats.org/drawingml/2006/main">
               <a:ext uri="{FF2B5EF4-FFF2-40B4-BE49-F238E27FC236}">
-                <a16:creationId xmlns:a16="http://schemas.microsoft.com/office/drawing/2014/main" id="{9077EEF1-D754-4DAA-9255-F32BB2379F42}"/>
+                <a16:creationId xmlns:a16="http://schemas.microsoft.com/office/drawing/2014/main" id="{9879A8D7-620A-445E-A8F3-7386A93B7ABA}"/>
               </a:ext>
             </a:extLst>
           </p:cNvPr>
@@ -7213,7 +7213,7 @@
                 <a:ea typeface="Aptos"/>
                 <a:cs typeface="Aptos"/>
               </a:rPr>
-              <a:t>A general-domain multilingual reranker hurts ranking quality.</a:t>
+              <a:t>Legal-domain fine-tuning fixes much of the pretrained mismatch.</a:t>
             </a:r>
           </a:p>
         </p:txBody>
@@ -7223,7 +7223,7 @@
           <p:cNvPr id="3" name="">
             <a:extLst xmlns:a="http://schemas.openxmlformats.org/drawingml/2006/main">
               <a:ext uri="{FF2B5EF4-FFF2-40B4-BE49-F238E27FC236}">
-                <a16:creationId xmlns:a16="http://schemas.microsoft.com/office/drawing/2014/main" id="{55905EED-6A41-4A91-B138-21A273A89458}"/>
+                <a16:creationId xmlns:a16="http://schemas.microsoft.com/office/drawing/2014/main" id="{CF7FE512-EC10-45D9-9690-E9DD09AF7332}"/>
               </a:ext>
             </a:extLst>
           </p:cNvPr>
@@ -7256,19 +7256,19 @@
           <p:cNvPr id="4" name="">
             <a:extLst xmlns:a="http://schemas.openxmlformats.org/drawingml/2006/main">
               <a:ext uri="{FF2B5EF4-FFF2-40B4-BE49-F238E27FC236}">
-                <a16:creationId xmlns:a16="http://schemas.microsoft.com/office/drawing/2014/main" id="{171E41F9-5595-4E6B-A6ED-EC5C5B32AE12}"/>
-              </a:ext>
-            </a:extLst>
-          </p:cNvPr>
-          <p:cNvSpPr>
-            <a:spLocks xmlns:a="http://schemas.openxmlformats.org/drawingml/2006/main" noGrp="1"/>
-          </p:cNvSpPr>
-          <p:nvPr/>
-        </p:nvSpPr>
-        <p:spPr>
-          <a:xfrm xmlns:a="http://schemas.openxmlformats.org/drawingml/2006/main">
-            <a:off x="1143000" y="2190750"/>
-            <a:ext cx="2476500" cy="1143000"/>
+                <a16:creationId xmlns:a16="http://schemas.microsoft.com/office/drawing/2014/main" id="{7AF7F100-1838-43CB-A12C-1F7057023A58}"/>
+              </a:ext>
+            </a:extLst>
+          </p:cNvPr>
+          <p:cNvSpPr>
+            <a:spLocks xmlns:a="http://schemas.openxmlformats.org/drawingml/2006/main" noGrp="1"/>
+          </p:cNvSpPr>
+          <p:nvPr/>
+        </p:nvSpPr>
+        <p:spPr>
+          <a:xfrm xmlns:a="http://schemas.openxmlformats.org/drawingml/2006/main">
+            <a:off x="857250" y="2143125"/>
+            <a:ext cx="2286000" cy="1143000"/>
           </a:xfrm>
           <a:prstGeom xmlns:a="http://schemas.openxmlformats.org/drawingml/2006/main" prst="rect">
             <a:avLst/>
@@ -7289,19 +7289,19 @@
           <p:cNvPr id="5" name="">
             <a:extLst xmlns:a="http://schemas.openxmlformats.org/drawingml/2006/main">
               <a:ext uri="{FF2B5EF4-FFF2-40B4-BE49-F238E27FC236}">
-                <a16:creationId xmlns:a16="http://schemas.microsoft.com/office/drawing/2014/main" id="{1C1C5FF0-2F42-4F99-8BCE-7E52192EB960}"/>
-              </a:ext>
-            </a:extLst>
-          </p:cNvPr>
-          <p:cNvSpPr>
-            <a:spLocks xmlns:a="http://schemas.openxmlformats.org/drawingml/2006/main" noGrp="1"/>
-          </p:cNvSpPr>
-          <p:nvPr/>
-        </p:nvSpPr>
-        <p:spPr>
-          <a:xfrm xmlns:a="http://schemas.openxmlformats.org/drawingml/2006/main">
-            <a:off x="1276350" y="2324100"/>
-            <a:ext cx="2209800" cy="419100"/>
+                <a16:creationId xmlns:a16="http://schemas.microsoft.com/office/drawing/2014/main" id="{4DFE4B29-54C8-4A09-B9CE-98ED279554AB}"/>
+              </a:ext>
+            </a:extLst>
+          </p:cNvPr>
+          <p:cNvSpPr>
+            <a:spLocks xmlns:a="http://schemas.openxmlformats.org/drawingml/2006/main" noGrp="1"/>
+          </p:cNvSpPr>
+          <p:nvPr/>
+        </p:nvSpPr>
+        <p:spPr>
+          <a:xfrm xmlns:a="http://schemas.openxmlformats.org/drawingml/2006/main">
+            <a:off x="990600" y="2276475"/>
+            <a:ext cx="2019300" cy="419100"/>
           </a:xfrm>
           <a:prstGeom xmlns:a="http://schemas.openxmlformats.org/drawingml/2006/main" prst="rect">
             <a:avLst/>
@@ -7323,7 +7323,7 @@
             <a:pPr algn="l">
               <a:defRPr sz="2250" b="1">
                 <a:solidFill>
-                  <a:srgbClr val="1B7F5A"/>
+                  <a:srgbClr val="B42318"/>
                 </a:solidFill>
                 <a:latin typeface="Aptos"/>
                 <a:ea typeface="Aptos"/>
@@ -7333,13 +7333,13 @@
             <a:r>
               <a:rPr sz="2250" b="1">
                 <a:solidFill>
-                  <a:srgbClr val="1B7F5A"/>
-                </a:solidFill>
-                <a:latin typeface="Aptos"/>
-                <a:ea typeface="Aptos"/>
-                <a:cs typeface="Aptos"/>
-              </a:rPr>
-              <a:t>1.000</a:t>
+                  <a:srgbClr val="B42318"/>
+                </a:solidFill>
+                <a:latin typeface="Aptos"/>
+                <a:ea typeface="Aptos"/>
+                <a:cs typeface="Aptos"/>
+              </a:rPr>
+              <a:t>0.810</a:t>
             </a:r>
           </a:p>
         </p:txBody>
@@ -7349,19 +7349,19 @@
           <p:cNvPr id="6" name="">
             <a:extLst xmlns:a="http://schemas.openxmlformats.org/drawingml/2006/main">
               <a:ext uri="{FF2B5EF4-FFF2-40B4-BE49-F238E27FC236}">
-                <a16:creationId xmlns:a16="http://schemas.microsoft.com/office/drawing/2014/main" id="{F70EEC46-3A92-4942-86FD-43044F6D8E04}"/>
-              </a:ext>
-            </a:extLst>
-          </p:cNvPr>
-          <p:cNvSpPr>
-            <a:spLocks xmlns:a="http://schemas.openxmlformats.org/drawingml/2006/main" noGrp="1"/>
-          </p:cNvSpPr>
-          <p:nvPr/>
-        </p:nvSpPr>
-        <p:spPr>
-          <a:xfrm xmlns:a="http://schemas.openxmlformats.org/drawingml/2006/main">
-            <a:off x="1276350" y="2762250"/>
-            <a:ext cx="2209800" cy="400050"/>
+                <a16:creationId xmlns:a16="http://schemas.microsoft.com/office/drawing/2014/main" id="{662A3427-60C2-409A-9EBF-C0010A5D710B}"/>
+              </a:ext>
+            </a:extLst>
+          </p:cNvPr>
+          <p:cNvSpPr>
+            <a:spLocks xmlns:a="http://schemas.openxmlformats.org/drawingml/2006/main" noGrp="1"/>
+          </p:cNvSpPr>
+          <p:nvPr/>
+        </p:nvSpPr>
+        <p:spPr>
+          <a:xfrm xmlns:a="http://schemas.openxmlformats.org/drawingml/2006/main">
+            <a:off x="990600" y="2714625"/>
+            <a:ext cx="2019300" cy="400050"/>
           </a:xfrm>
           <a:prstGeom xmlns:a="http://schemas.openxmlformats.org/drawingml/2006/main" prst="rect">
             <a:avLst/>
@@ -7399,7 +7399,7 @@
                 <a:ea typeface="Aptos"/>
                 <a:cs typeface="Aptos"/>
               </a:rPr>
-              <a:t>BM25 first-stage Recall@10</a:t>
+              <a:t>Pretrained Recall@10, 100q</a:t>
             </a:r>
           </a:p>
         </p:txBody>
@@ -7409,19 +7409,19 @@
           <p:cNvPr id="7" name="">
             <a:extLst xmlns:a="http://schemas.openxmlformats.org/drawingml/2006/main">
               <a:ext uri="{FF2B5EF4-FFF2-40B4-BE49-F238E27FC236}">
-                <a16:creationId xmlns:a16="http://schemas.microsoft.com/office/drawing/2014/main" id="{46CB1194-3EB7-47F7-AEB0-1E6890CEBE15}"/>
-              </a:ext>
-            </a:extLst>
-          </p:cNvPr>
-          <p:cNvSpPr>
-            <a:spLocks xmlns:a="http://schemas.openxmlformats.org/drawingml/2006/main" noGrp="1"/>
-          </p:cNvSpPr>
-          <p:nvPr/>
-        </p:nvSpPr>
-        <p:spPr>
-          <a:xfrm xmlns:a="http://schemas.openxmlformats.org/drawingml/2006/main">
-            <a:off x="4191000" y="2190750"/>
-            <a:ext cx="2476500" cy="1143000"/>
+                <a16:creationId xmlns:a16="http://schemas.microsoft.com/office/drawing/2014/main" id="{DD8DBAD3-DAD7-4C85-BE73-F8B1855972A9}"/>
+              </a:ext>
+            </a:extLst>
+          </p:cNvPr>
+          <p:cNvSpPr>
+            <a:spLocks xmlns:a="http://schemas.openxmlformats.org/drawingml/2006/main" noGrp="1"/>
+          </p:cNvSpPr>
+          <p:nvPr/>
+        </p:nvSpPr>
+        <p:spPr>
+          <a:xfrm xmlns:a="http://schemas.openxmlformats.org/drawingml/2006/main">
+            <a:off x="3476625" y="2143125"/>
+            <a:ext cx="2286000" cy="1143000"/>
           </a:xfrm>
           <a:prstGeom xmlns:a="http://schemas.openxmlformats.org/drawingml/2006/main" prst="rect">
             <a:avLst/>
@@ -7442,19 +7442,19 @@
           <p:cNvPr id="8" name="">
             <a:extLst xmlns:a="http://schemas.openxmlformats.org/drawingml/2006/main">
               <a:ext uri="{FF2B5EF4-FFF2-40B4-BE49-F238E27FC236}">
-                <a16:creationId xmlns:a16="http://schemas.microsoft.com/office/drawing/2014/main" id="{AA92104F-C02A-401E-B835-0559A1A616C3}"/>
-              </a:ext>
-            </a:extLst>
-          </p:cNvPr>
-          <p:cNvSpPr>
-            <a:spLocks xmlns:a="http://schemas.openxmlformats.org/drawingml/2006/main" noGrp="1"/>
-          </p:cNvSpPr>
-          <p:nvPr/>
-        </p:nvSpPr>
-        <p:spPr>
-          <a:xfrm xmlns:a="http://schemas.openxmlformats.org/drawingml/2006/main">
-            <a:off x="4324350" y="2324100"/>
-            <a:ext cx="2209800" cy="419100"/>
+                <a16:creationId xmlns:a16="http://schemas.microsoft.com/office/drawing/2014/main" id="{1F7547ED-FBF4-4B10-8475-E64749FF985A}"/>
+              </a:ext>
+            </a:extLst>
+          </p:cNvPr>
+          <p:cNvSpPr>
+            <a:spLocks xmlns:a="http://schemas.openxmlformats.org/drawingml/2006/main" noGrp="1"/>
+          </p:cNvSpPr>
+          <p:nvPr/>
+        </p:nvSpPr>
+        <p:spPr>
+          <a:xfrm xmlns:a="http://schemas.openxmlformats.org/drawingml/2006/main">
+            <a:off x="3609975" y="2276475"/>
+            <a:ext cx="2019300" cy="419100"/>
           </a:xfrm>
           <a:prstGeom xmlns:a="http://schemas.openxmlformats.org/drawingml/2006/main" prst="rect">
             <a:avLst/>
@@ -7476,7 +7476,7 @@
             <a:pPr algn="l">
               <a:defRPr sz="2250" b="1">
                 <a:solidFill>
-                  <a:srgbClr val="B42318"/>
+                  <a:srgbClr val="1B7F5A"/>
                 </a:solidFill>
                 <a:latin typeface="Aptos"/>
                 <a:ea typeface="Aptos"/>
@@ -7486,13 +7486,13 @@
             <a:r>
               <a:rPr sz="2250" b="1">
                 <a:solidFill>
-                  <a:srgbClr val="B42318"/>
-                </a:solidFill>
-                <a:latin typeface="Aptos"/>
-                <a:ea typeface="Aptos"/>
-                <a:cs typeface="Aptos"/>
-              </a:rPr>
-              <a:t>0.810</a:t>
+                  <a:srgbClr val="1B7F5A"/>
+                </a:solidFill>
+                <a:latin typeface="Aptos"/>
+                <a:ea typeface="Aptos"/>
+                <a:cs typeface="Aptos"/>
+              </a:rPr>
+              <a:t>0.970</a:t>
             </a:r>
           </a:p>
         </p:txBody>
@@ -7502,19 +7502,19 @@
           <p:cNvPr id="9" name="">
             <a:extLst xmlns:a="http://schemas.openxmlformats.org/drawingml/2006/main">
               <a:ext uri="{FF2B5EF4-FFF2-40B4-BE49-F238E27FC236}">
-                <a16:creationId xmlns:a16="http://schemas.microsoft.com/office/drawing/2014/main" id="{120CABD0-BB8E-45CE-8D06-0D8FD86C2F3B}"/>
-              </a:ext>
-            </a:extLst>
-          </p:cNvPr>
-          <p:cNvSpPr>
-            <a:spLocks xmlns:a="http://schemas.openxmlformats.org/drawingml/2006/main" noGrp="1"/>
-          </p:cNvSpPr>
-          <p:nvPr/>
-        </p:nvSpPr>
-        <p:spPr>
-          <a:xfrm xmlns:a="http://schemas.openxmlformats.org/drawingml/2006/main">
-            <a:off x="4324350" y="2762250"/>
-            <a:ext cx="2209800" cy="400050"/>
+                <a16:creationId xmlns:a16="http://schemas.microsoft.com/office/drawing/2014/main" id="{2F5ABD75-72FA-489D-9C9A-1DE5719EF95D}"/>
+              </a:ext>
+            </a:extLst>
+          </p:cNvPr>
+          <p:cNvSpPr>
+            <a:spLocks xmlns:a="http://schemas.openxmlformats.org/drawingml/2006/main" noGrp="1"/>
+          </p:cNvSpPr>
+          <p:nvPr/>
+        </p:nvSpPr>
+        <p:spPr>
+          <a:xfrm xmlns:a="http://schemas.openxmlformats.org/drawingml/2006/main">
+            <a:off x="3609975" y="2714625"/>
+            <a:ext cx="2019300" cy="400050"/>
           </a:xfrm>
           <a:prstGeom xmlns:a="http://schemas.openxmlformats.org/drawingml/2006/main" prst="rect">
             <a:avLst/>
@@ -7552,7 +7552,7 @@
                 <a:ea typeface="Aptos"/>
                 <a:cs typeface="Aptos"/>
               </a:rPr>
-              <a:t>Pretrained reranker Recall@10</a:t>
+              <a:t>Fine-tuned Recall@10, 100q</a:t>
             </a:r>
           </a:p>
         </p:txBody>
@@ -7562,19 +7562,19 @@
           <p:cNvPr id="10" name="">
             <a:extLst xmlns:a="http://schemas.openxmlformats.org/drawingml/2006/main">
               <a:ext uri="{FF2B5EF4-FFF2-40B4-BE49-F238E27FC236}">
-                <a16:creationId xmlns:a16="http://schemas.microsoft.com/office/drawing/2014/main" id="{4823BB7E-DF3E-4DA2-9282-4F737EB4B382}"/>
-              </a:ext>
-            </a:extLst>
-          </p:cNvPr>
-          <p:cNvSpPr>
-            <a:spLocks xmlns:a="http://schemas.openxmlformats.org/drawingml/2006/main" noGrp="1"/>
-          </p:cNvSpPr>
-          <p:nvPr/>
-        </p:nvSpPr>
-        <p:spPr>
-          <a:xfrm xmlns:a="http://schemas.openxmlformats.org/drawingml/2006/main">
-            <a:off x="7239000" y="2190750"/>
-            <a:ext cx="2476500" cy="1143000"/>
+                <a16:creationId xmlns:a16="http://schemas.microsoft.com/office/drawing/2014/main" id="{AAC63E0D-F7AF-4DA1-9D3B-EE7142AE0864}"/>
+              </a:ext>
+            </a:extLst>
+          </p:cNvPr>
+          <p:cNvSpPr>
+            <a:spLocks xmlns:a="http://schemas.openxmlformats.org/drawingml/2006/main" noGrp="1"/>
+          </p:cNvSpPr>
+          <p:nvPr/>
+        </p:nvSpPr>
+        <p:spPr>
+          <a:xfrm xmlns:a="http://schemas.openxmlformats.org/drawingml/2006/main">
+            <a:off x="6096000" y="2143125"/>
+            <a:ext cx="2286000" cy="1143000"/>
           </a:xfrm>
           <a:prstGeom xmlns:a="http://schemas.openxmlformats.org/drawingml/2006/main" prst="rect">
             <a:avLst/>
@@ -7595,19 +7595,19 @@
           <p:cNvPr id="11" name="">
             <a:extLst xmlns:a="http://schemas.openxmlformats.org/drawingml/2006/main">
               <a:ext uri="{FF2B5EF4-FFF2-40B4-BE49-F238E27FC236}">
-                <a16:creationId xmlns:a16="http://schemas.microsoft.com/office/drawing/2014/main" id="{BD806E7C-517F-4862-84F3-A47071C24E40}"/>
-              </a:ext>
-            </a:extLst>
-          </p:cNvPr>
-          <p:cNvSpPr>
-            <a:spLocks xmlns:a="http://schemas.openxmlformats.org/drawingml/2006/main" noGrp="1"/>
-          </p:cNvSpPr>
-          <p:nvPr/>
-        </p:nvSpPr>
-        <p:spPr>
-          <a:xfrm xmlns:a="http://schemas.openxmlformats.org/drawingml/2006/main">
-            <a:off x="7372350" y="2324100"/>
-            <a:ext cx="2209800" cy="419100"/>
+                <a16:creationId xmlns:a16="http://schemas.microsoft.com/office/drawing/2014/main" id="{7876F68C-B81A-474B-9D4F-8D0DD2F8F3D9}"/>
+              </a:ext>
+            </a:extLst>
+          </p:cNvPr>
+          <p:cNvSpPr>
+            <a:spLocks xmlns:a="http://schemas.openxmlformats.org/drawingml/2006/main" noGrp="1"/>
+          </p:cNvSpPr>
+          <p:nvPr/>
+        </p:nvSpPr>
+        <p:spPr>
+          <a:xfrm xmlns:a="http://schemas.openxmlformats.org/drawingml/2006/main">
+            <a:off x="6229350" y="2276475"/>
+            <a:ext cx="2019300" cy="419100"/>
           </a:xfrm>
           <a:prstGeom xmlns:a="http://schemas.openxmlformats.org/drawingml/2006/main" prst="rect">
             <a:avLst/>
@@ -7629,7 +7629,7 @@
             <a:pPr algn="l">
               <a:defRPr sz="2250" b="1">
                 <a:solidFill>
-                  <a:srgbClr val="B42318"/>
+                  <a:srgbClr val="2E74B5"/>
                 </a:solidFill>
                 <a:latin typeface="Aptos"/>
                 <a:ea typeface="Aptos"/>
@@ -7639,13 +7639,13 @@
             <a:r>
               <a:rPr sz="2250" b="1">
                 <a:solidFill>
-                  <a:srgbClr val="B42318"/>
-                </a:solidFill>
-                <a:latin typeface="Aptos"/>
-                <a:ea typeface="Aptos"/>
-                <a:cs typeface="Aptos"/>
-              </a:rPr>
-              <a:t>0.550</a:t>
+                  <a:srgbClr val="2E74B5"/>
+                </a:solidFill>
+                <a:latin typeface="Aptos"/>
+                <a:ea typeface="Aptos"/>
+                <a:cs typeface="Aptos"/>
+              </a:rPr>
+              <a:t>0.915</a:t>
             </a:r>
           </a:p>
         </p:txBody>
@@ -7655,19 +7655,19 @@
           <p:cNvPr id="12" name="">
             <a:extLst xmlns:a="http://schemas.openxmlformats.org/drawingml/2006/main">
               <a:ext uri="{FF2B5EF4-FFF2-40B4-BE49-F238E27FC236}">
-                <a16:creationId xmlns:a16="http://schemas.microsoft.com/office/drawing/2014/main" id="{C215FBE9-5EB7-4802-83D2-757D69EB1288}"/>
-              </a:ext>
-            </a:extLst>
-          </p:cNvPr>
-          <p:cNvSpPr>
-            <a:spLocks xmlns:a="http://schemas.openxmlformats.org/drawingml/2006/main" noGrp="1"/>
-          </p:cNvSpPr>
-          <p:nvPr/>
-        </p:nvSpPr>
-        <p:spPr>
-          <a:xfrm xmlns:a="http://schemas.openxmlformats.org/drawingml/2006/main">
-            <a:off x="7372350" y="2762250"/>
-            <a:ext cx="2209800" cy="400050"/>
+                <a16:creationId xmlns:a16="http://schemas.microsoft.com/office/drawing/2014/main" id="{7A39730C-06ED-40E9-BD77-FFB484485811}"/>
+              </a:ext>
+            </a:extLst>
+          </p:cNvPr>
+          <p:cNvSpPr>
+            <a:spLocks xmlns:a="http://schemas.openxmlformats.org/drawingml/2006/main" noGrp="1"/>
+          </p:cNvSpPr>
+          <p:nvPr/>
+        </p:nvSpPr>
+        <p:spPr>
+          <a:xfrm xmlns:a="http://schemas.openxmlformats.org/drawingml/2006/main">
+            <a:off x="6229350" y="2714625"/>
+            <a:ext cx="2019300" cy="400050"/>
           </a:xfrm>
           <a:prstGeom xmlns:a="http://schemas.openxmlformats.org/drawingml/2006/main" prst="rect">
             <a:avLst/>
@@ -7705,7 +7705,7 @@
                 <a:ea typeface="Aptos"/>
                 <a:cs typeface="Aptos"/>
               </a:rPr>
-              <a:t>Pretrained reranker MRR</a:t>
+              <a:t>Fine-tuned Recall@10, 1000q</a:t>
             </a:r>
           </a:p>
         </p:txBody>
@@ -7715,7 +7715,160 @@
           <p:cNvPr id="13" name="">
             <a:extLst xmlns:a="http://schemas.openxmlformats.org/drawingml/2006/main">
               <a:ext uri="{FF2B5EF4-FFF2-40B4-BE49-F238E27FC236}">
-                <a16:creationId xmlns:a16="http://schemas.microsoft.com/office/drawing/2014/main" id="{1BC4D94A-B7ED-409C-B0A6-D5D099CDC4B3}"/>
+                <a16:creationId xmlns:a16="http://schemas.microsoft.com/office/drawing/2014/main" id="{05CE3477-7F9D-42F2-9C93-A81F6509DB4E}"/>
+              </a:ext>
+            </a:extLst>
+          </p:cNvPr>
+          <p:cNvSpPr>
+            <a:spLocks xmlns:a="http://schemas.openxmlformats.org/drawingml/2006/main" noGrp="1"/>
+          </p:cNvSpPr>
+          <p:nvPr/>
+        </p:nvSpPr>
+        <p:spPr>
+          <a:xfrm xmlns:a="http://schemas.openxmlformats.org/drawingml/2006/main">
+            <a:off x="8715375" y="2143125"/>
+            <a:ext cx="2286000" cy="1143000"/>
+          </a:xfrm>
+          <a:prstGeom xmlns:a="http://schemas.openxmlformats.org/drawingml/2006/main" prst="rect">
+            <a:avLst/>
+          </a:prstGeom>
+          <a:solidFill xmlns:a="http://schemas.openxmlformats.org/drawingml/2006/main">
+            <a:srgbClr val="F4F7FB"/>
+          </a:solidFill>
+          <a:ln xmlns:a="http://schemas.openxmlformats.org/drawingml/2006/main" w="9525">
+            <a:solidFill>
+              <a:srgbClr val="D6DEE9"/>
+            </a:solidFill>
+            <a:prstDash val="solid"/>
+          </a:ln>
+        </p:spPr>
+      </p:sp>
+      <p:sp>
+        <p:nvSpPr>
+          <p:cNvPr id="14" name="">
+            <a:extLst xmlns:a="http://schemas.openxmlformats.org/drawingml/2006/main">
+              <a:ext uri="{FF2B5EF4-FFF2-40B4-BE49-F238E27FC236}">
+                <a16:creationId xmlns:a16="http://schemas.microsoft.com/office/drawing/2014/main" id="{66913203-71E5-4B0E-A9FD-0B692755D626}"/>
+              </a:ext>
+            </a:extLst>
+          </p:cNvPr>
+          <p:cNvSpPr>
+            <a:spLocks xmlns:a="http://schemas.openxmlformats.org/drawingml/2006/main" noGrp="1"/>
+          </p:cNvSpPr>
+          <p:nvPr/>
+        </p:nvSpPr>
+        <p:spPr>
+          <a:xfrm xmlns:a="http://schemas.openxmlformats.org/drawingml/2006/main">
+            <a:off x="8848725" y="2276475"/>
+            <a:ext cx="2019300" cy="419100"/>
+          </a:xfrm>
+          <a:prstGeom xmlns:a="http://schemas.openxmlformats.org/drawingml/2006/main" prst="rect">
+            <a:avLst/>
+          </a:prstGeom>
+          <a:solidFill xmlns:a="http://schemas.openxmlformats.org/drawingml/2006/main">
+            <a:srgbClr val="F4F7FB"/>
+          </a:solidFill>
+          <a:ln xmlns:a="http://schemas.openxmlformats.org/drawingml/2006/main" w="9525">
+            <a:solidFill>
+              <a:srgbClr val="F4F7FB"/>
+            </a:solidFill>
+            <a:prstDash val="solid"/>
+          </a:ln>
+        </p:spPr>
+        <p:txBody>
+          <a:bodyPr xmlns:a="http://schemas.openxmlformats.org/drawingml/2006/main" lIns="95250" tIns="57150" rIns="95250" bIns="57150" anchor="t"/>
+          <a:lstStyle xmlns:a="http://schemas.openxmlformats.org/drawingml/2006/main"/>
+          <a:p xmlns:a="http://schemas.openxmlformats.org/drawingml/2006/main">
+            <a:pPr algn="l">
+              <a:defRPr sz="2250" b="1">
+                <a:solidFill>
+                  <a:srgbClr val="1B7F5A"/>
+                </a:solidFill>
+                <a:latin typeface="Aptos"/>
+                <a:ea typeface="Aptos"/>
+                <a:cs typeface="Aptos"/>
+              </a:defRPr>
+            </a:pPr>
+            <a:r>
+              <a:rPr sz="2250" b="1">
+                <a:solidFill>
+                  <a:srgbClr val="1B7F5A"/>
+                </a:solidFill>
+                <a:latin typeface="Aptos"/>
+                <a:ea typeface="Aptos"/>
+                <a:cs typeface="Aptos"/>
+              </a:rPr>
+              <a:t>0.975</a:t>
+            </a:r>
+          </a:p>
+        </p:txBody>
+      </p:sp>
+      <p:sp>
+        <p:nvSpPr>
+          <p:cNvPr id="15" name="">
+            <a:extLst xmlns:a="http://schemas.openxmlformats.org/drawingml/2006/main">
+              <a:ext uri="{FF2B5EF4-FFF2-40B4-BE49-F238E27FC236}">
+                <a16:creationId xmlns:a16="http://schemas.microsoft.com/office/drawing/2014/main" id="{725F23B1-34A1-4739-A392-AA9B2B08B2BF}"/>
+              </a:ext>
+            </a:extLst>
+          </p:cNvPr>
+          <p:cNvSpPr>
+            <a:spLocks xmlns:a="http://schemas.openxmlformats.org/drawingml/2006/main" noGrp="1"/>
+          </p:cNvSpPr>
+          <p:nvPr/>
+        </p:nvSpPr>
+        <p:spPr>
+          <a:xfrm xmlns:a="http://schemas.openxmlformats.org/drawingml/2006/main">
+            <a:off x="8848725" y="2714625"/>
+            <a:ext cx="2019300" cy="400050"/>
+          </a:xfrm>
+          <a:prstGeom xmlns:a="http://schemas.openxmlformats.org/drawingml/2006/main" prst="rect">
+            <a:avLst/>
+          </a:prstGeom>
+          <a:solidFill xmlns:a="http://schemas.openxmlformats.org/drawingml/2006/main">
+            <a:srgbClr val="F4F7FB"/>
+          </a:solidFill>
+          <a:ln xmlns:a="http://schemas.openxmlformats.org/drawingml/2006/main" w="9525">
+            <a:solidFill>
+              <a:srgbClr val="F4F7FB"/>
+            </a:solidFill>
+            <a:prstDash val="solid"/>
+          </a:ln>
+        </p:spPr>
+        <p:txBody>
+          <a:bodyPr xmlns:a="http://schemas.openxmlformats.org/drawingml/2006/main" lIns="95250" tIns="57150" rIns="95250" bIns="57150" anchor="t"/>
+          <a:lstStyle xmlns:a="http://schemas.openxmlformats.org/drawingml/2006/main"/>
+          <a:p xmlns:a="http://schemas.openxmlformats.org/drawingml/2006/main">
+            <a:pPr algn="l">
+              <a:defRPr sz="1050" b="0">
+                <a:solidFill>
+                  <a:srgbClr val="667085"/>
+                </a:solidFill>
+                <a:latin typeface="Aptos"/>
+                <a:ea typeface="Aptos"/>
+                <a:cs typeface="Aptos"/>
+              </a:defRPr>
+            </a:pPr>
+            <a:r>
+              <a:rPr sz="1050" b="0">
+                <a:solidFill>
+                  <a:srgbClr val="667085"/>
+                </a:solidFill>
+                <a:latin typeface="Aptos"/>
+                <a:ea typeface="Aptos"/>
+                <a:cs typeface="Aptos"/>
+              </a:rPr>
+              <a:t>BM25 Recall@10, 1000q</a:t>
+            </a:r>
+          </a:p>
+        </p:txBody>
+      </p:sp>
+      <p:sp>
+        <p:nvSpPr>
+          <p:cNvPr id="16" name="">
+            <a:extLst xmlns:a="http://schemas.openxmlformats.org/drawingml/2006/main">
+              <a:ext uri="{FF2B5EF4-FFF2-40B4-BE49-F238E27FC236}">
+                <a16:creationId xmlns:a16="http://schemas.microsoft.com/office/drawing/2014/main" id="{B598A023-2E16-449D-970A-0BE9910A3311}"/>
               </a:ext>
             </a:extLst>
           </p:cNvPr>
@@ -7733,11 +7886,11 @@
             <a:avLst/>
           </a:prstGeom>
           <a:solidFill xmlns:a="http://schemas.openxmlformats.org/drawingml/2006/main">
-            <a:srgbClr val="FFF1F0"/>
-          </a:solidFill>
-          <a:ln xmlns:a="http://schemas.openxmlformats.org/drawingml/2006/main" w="9525">
-            <a:solidFill>
-              <a:srgbClr val="FDA29B"/>
+            <a:srgbClr val="EAF7F1"/>
+          </a:solidFill>
+          <a:ln xmlns:a="http://schemas.openxmlformats.org/drawingml/2006/main" w="9525">
+            <a:solidFill>
+              <a:srgbClr val="A6D8BF"/>
             </a:solidFill>
             <a:prstDash val="solid"/>
           </a:ln>
@@ -7747,7 +7900,7 @@
           <a:lstStyle xmlns:a="http://schemas.openxmlformats.org/drawingml/2006/main"/>
           <a:p xmlns:a="http://schemas.openxmlformats.org/drawingml/2006/main">
             <a:pPr algn="ctr">
-              <a:defRPr sz="1800" b="1">
+              <a:defRPr sz="1650" b="1">
                 <a:solidFill>
                   <a:srgbClr val="0B2545"/>
                 </a:solidFill>
@@ -7757,7 +7910,7 @@
               </a:defRPr>
             </a:pPr>
             <a:r>
-              <a:rPr sz="1800" b="1">
+              <a:rPr sz="1650" b="1">
                 <a:solidFill>
                   <a:srgbClr val="0B2545"/>
                 </a:solidFill>
@@ -7765,17 +7918,17 @@
                 <a:ea typeface="Aptos"/>
                 <a:cs typeface="Aptos"/>
               </a:rPr>
-              <a:t>Conclusion: the reranker has domain mismatch. The project includes a cross-encoder fine-tuning script using reranker.jsonl.</a:t>
-            </a:r>
-          </a:p>
-        </p:txBody>
-      </p:sp>
-      <p:sp>
-        <p:nvSpPr>
-          <p:cNvPr id="14" name="">
-            <a:extLst xmlns:a="http://schemas.openxmlformats.org/drawingml/2006/main">
-              <a:ext uri="{FF2B5EF4-FFF2-40B4-BE49-F238E27FC236}">
-                <a16:creationId xmlns:a16="http://schemas.microsoft.com/office/drawing/2014/main" id="{EC1C53E0-DE5A-4282-A039-D5FFB9054BCC}"/>
+              <a:t>Conclusion: reranker fine-tuning works, but raw BM25 remains strongest on the full benchmark, so the live demo keeps BM25 ranking.</a:t>
+            </a:r>
+          </a:p>
+        </p:txBody>
+      </p:sp>
+      <p:sp>
+        <p:nvSpPr>
+          <p:cNvPr id="17" name="">
+            <a:extLst xmlns:a="http://schemas.openxmlformats.org/drawingml/2006/main">
+              <a:ext uri="{FF2B5EF4-FFF2-40B4-BE49-F238E27FC236}">
+                <a16:creationId xmlns:a16="http://schemas.microsoft.com/office/drawing/2014/main" id="{F49B29C9-4A08-438B-97A7-457A1941E1AD}"/>
               </a:ext>
             </a:extLst>
           </p:cNvPr>
@@ -7833,7 +7986,7 @@
     </p:spTree>
     <p:extLst>
       <p:ext uri="{BB962C8B-B14F-4D97-AF65-F5344CB8AC3E}">
-        <p14:creationId xmlns:p14="http://schemas.microsoft.com/office/powerpoint/2010/main" val="1212346044"/>
+        <p14:creationId xmlns:p14="http://schemas.microsoft.com/office/powerpoint/2010/main" val="1179893712"/>
       </p:ext>
     </p:extLst>
   </p:cSld>
@@ -7857,7 +8010,7 @@
           <p:cNvPr id="1" name="">
             <a:extLst xmlns:a="http://schemas.openxmlformats.org/drawingml/2006/main">
               <a:ext uri="{FF2B5EF4-FFF2-40B4-BE49-F238E27FC236}">
-                <a16:creationId xmlns:a16="http://schemas.microsoft.com/office/drawing/2014/main" id="{34943D8F-6D53-43E6-9C95-A2DF259A7134}"/>
+                <a16:creationId xmlns:a16="http://schemas.microsoft.com/office/drawing/2014/main" id="{5596690E-6E69-4FCB-ACF7-59764301279E}"/>
               </a:ext>
             </a:extLst>
           </p:cNvPr>
@@ -7917,7 +8070,7 @@
           <p:cNvPr id="2" name="">
             <a:extLst xmlns:a="http://schemas.openxmlformats.org/drawingml/2006/main">
               <a:ext uri="{FF2B5EF4-FFF2-40B4-BE49-F238E27FC236}">
-                <a16:creationId xmlns:a16="http://schemas.microsoft.com/office/drawing/2014/main" id="{A6347068-29D6-49AD-8AC9-C2D47CFDD916}"/>
+                <a16:creationId xmlns:a16="http://schemas.microsoft.com/office/drawing/2014/main" id="{6C7E96E6-08B1-4603-BC62-51461AC53209}"/>
               </a:ext>
             </a:extLst>
           </p:cNvPr>
@@ -7967,7 +8120,7 @@
                 <a:ea typeface="Aptos"/>
                 <a:cs typeface="Aptos"/>
               </a:rPr>
-              <a:t>Dense retrieval needs Turkish legal domain adaptation.</a:t>
+              <a:t>Dense fine-tuning must be validated, not assumed to help.</a:t>
             </a:r>
           </a:p>
         </p:txBody>
@@ -7977,7 +8130,7 @@
           <p:cNvPr id="3" name="">
             <a:extLst xmlns:a="http://schemas.openxmlformats.org/drawingml/2006/main">
               <a:ext uri="{FF2B5EF4-FFF2-40B4-BE49-F238E27FC236}">
-                <a16:creationId xmlns:a16="http://schemas.microsoft.com/office/drawing/2014/main" id="{97330858-C8E3-4C86-8AD5-BE1053CD8D3A}"/>
+                <a16:creationId xmlns:a16="http://schemas.microsoft.com/office/drawing/2014/main" id="{70BCE8A8-8CFA-4A91-9D33-53275BD33A25}"/>
               </a:ext>
             </a:extLst>
           </p:cNvPr>
@@ -8010,29 +8163,62 @@
           <p:cNvPr id="4" name="">
             <a:extLst xmlns:a="http://schemas.openxmlformats.org/drawingml/2006/main">
               <a:ext uri="{FF2B5EF4-FFF2-40B4-BE49-F238E27FC236}">
-                <a16:creationId xmlns:a16="http://schemas.microsoft.com/office/drawing/2014/main" id="{25A38109-3CA1-42D2-A39C-114C27F82FDD}"/>
-              </a:ext>
-            </a:extLst>
-          </p:cNvPr>
-          <p:cNvSpPr>
-            <a:spLocks xmlns:a="http://schemas.openxmlformats.org/drawingml/2006/main" noGrp="1"/>
-          </p:cNvSpPr>
-          <p:nvPr/>
-        </p:nvSpPr>
-        <p:spPr>
-          <a:xfrm xmlns:a="http://schemas.openxmlformats.org/drawingml/2006/main">
-            <a:off x="857250" y="2095500"/>
-            <a:ext cx="2476500" cy="323850"/>
-          </a:xfrm>
-          <a:prstGeom xmlns:a="http://schemas.openxmlformats.org/drawingml/2006/main" prst="rect">
-            <a:avLst/>
-          </a:prstGeom>
-          <a:solidFill xmlns:a="http://schemas.openxmlformats.org/drawingml/2006/main">
-            <a:srgbClr val="FFFFFF"/>
-          </a:solidFill>
-          <a:ln xmlns:a="http://schemas.openxmlformats.org/drawingml/2006/main" w="9525">
-            <a:solidFill>
-              <a:srgbClr val="FFFFFF"/>
+                <a16:creationId xmlns:a16="http://schemas.microsoft.com/office/drawing/2014/main" id="{29FCA282-AC41-40D5-A24C-8E9EEB872B84}"/>
+              </a:ext>
+            </a:extLst>
+          </p:cNvPr>
+          <p:cNvSpPr>
+            <a:spLocks xmlns:a="http://schemas.openxmlformats.org/drawingml/2006/main" noGrp="1"/>
+          </p:cNvSpPr>
+          <p:nvPr/>
+        </p:nvSpPr>
+        <p:spPr>
+          <a:xfrm xmlns:a="http://schemas.openxmlformats.org/drawingml/2006/main">
+            <a:off x="1238250" y="2238375"/>
+            <a:ext cx="2381250" cy="1143000"/>
+          </a:xfrm>
+          <a:prstGeom xmlns:a="http://schemas.openxmlformats.org/drawingml/2006/main" prst="rect">
+            <a:avLst/>
+          </a:prstGeom>
+          <a:solidFill xmlns:a="http://schemas.openxmlformats.org/drawingml/2006/main">
+            <a:srgbClr val="F4F7FB"/>
+          </a:solidFill>
+          <a:ln xmlns:a="http://schemas.openxmlformats.org/drawingml/2006/main" w="9525">
+            <a:solidFill>
+              <a:srgbClr val="D6DEE9"/>
+            </a:solidFill>
+            <a:prstDash val="solid"/>
+          </a:ln>
+        </p:spPr>
+      </p:sp>
+      <p:sp>
+        <p:nvSpPr>
+          <p:cNvPr id="5" name="">
+            <a:extLst xmlns:a="http://schemas.openxmlformats.org/drawingml/2006/main">
+              <a:ext uri="{FF2B5EF4-FFF2-40B4-BE49-F238E27FC236}">
+                <a16:creationId xmlns:a16="http://schemas.microsoft.com/office/drawing/2014/main" id="{460EF35A-3512-42C6-AD0D-6237F7F56F49}"/>
+              </a:ext>
+            </a:extLst>
+          </p:cNvPr>
+          <p:cNvSpPr>
+            <a:spLocks xmlns:a="http://schemas.openxmlformats.org/drawingml/2006/main" noGrp="1"/>
+          </p:cNvSpPr>
+          <p:nvPr/>
+        </p:nvSpPr>
+        <p:spPr>
+          <a:xfrm xmlns:a="http://schemas.openxmlformats.org/drawingml/2006/main">
+            <a:off x="1371600" y="2371725"/>
+            <a:ext cx="2114550" cy="419100"/>
+          </a:xfrm>
+          <a:prstGeom xmlns:a="http://schemas.openxmlformats.org/drawingml/2006/main" prst="rect">
+            <a:avLst/>
+          </a:prstGeom>
+          <a:solidFill xmlns:a="http://schemas.openxmlformats.org/drawingml/2006/main">
+            <a:srgbClr val="F4F7FB"/>
+          </a:solidFill>
+          <a:ln xmlns:a="http://schemas.openxmlformats.org/drawingml/2006/main" w="9525">
+            <a:solidFill>
+              <a:srgbClr val="F4F7FB"/>
             </a:solidFill>
             <a:prstDash val="solid"/>
           </a:ln>
@@ -8042,7 +8228,7 @@
           <a:lstStyle xmlns:a="http://schemas.openxmlformats.org/drawingml/2006/main"/>
           <a:p xmlns:a="http://schemas.openxmlformats.org/drawingml/2006/main">
             <a:pPr algn="l">
-              <a:defRPr sz="1500" b="1">
+              <a:defRPr sz="2250" b="1">
                 <a:solidFill>
                   <a:srgbClr val="2E74B5"/>
                 </a:solidFill>
@@ -8052,7 +8238,7 @@
               </a:defRPr>
             </a:pPr>
             <a:r>
-              <a:rPr sz="1500" b="1">
+              <a:rPr sz="2250" b="1">
                 <a:solidFill>
                   <a:srgbClr val="2E74B5"/>
                 </a:solidFill>
@@ -8060,29 +8246,89 @@
                 <a:ea typeface="Aptos"/>
                 <a:cs typeface="Aptos"/>
               </a:rPr>
-              <a:t>Training signal</a:t>
-            </a:r>
-          </a:p>
-        </p:txBody>
-      </p:sp>
-      <p:sp>
-        <p:nvSpPr>
-          <p:cNvPr id="5" name="">
-            <a:extLst xmlns:a="http://schemas.openxmlformats.org/drawingml/2006/main">
-              <a:ext uri="{FF2B5EF4-FFF2-40B4-BE49-F238E27FC236}">
-                <a16:creationId xmlns:a16="http://schemas.microsoft.com/office/drawing/2014/main" id="{E1D9D91E-C067-4B6C-885F-CAAA5DB9B4CA}"/>
-              </a:ext>
-            </a:extLst>
-          </p:cNvPr>
-          <p:cNvSpPr>
-            <a:spLocks xmlns:a="http://schemas.openxmlformats.org/drawingml/2006/main" noGrp="1"/>
-          </p:cNvSpPr>
-          <p:nvPr/>
-        </p:nvSpPr>
-        <p:spPr>
-          <a:xfrm xmlns:a="http://schemas.openxmlformats.org/drawingml/2006/main">
-            <a:off x="952500" y="2857500"/>
-            <a:ext cx="2381250" cy="666750"/>
+              <a:t>0.676</a:t>
+            </a:r>
+          </a:p>
+        </p:txBody>
+      </p:sp>
+      <p:sp>
+        <p:nvSpPr>
+          <p:cNvPr id="6" name="">
+            <a:extLst xmlns:a="http://schemas.openxmlformats.org/drawingml/2006/main">
+              <a:ext uri="{FF2B5EF4-FFF2-40B4-BE49-F238E27FC236}">
+                <a16:creationId xmlns:a16="http://schemas.microsoft.com/office/drawing/2014/main" id="{400B1EF3-19E0-461B-9A04-03231AB9B227}"/>
+              </a:ext>
+            </a:extLst>
+          </p:cNvPr>
+          <p:cNvSpPr>
+            <a:spLocks xmlns:a="http://schemas.openxmlformats.org/drawingml/2006/main" noGrp="1"/>
+          </p:cNvSpPr>
+          <p:nvPr/>
+        </p:nvSpPr>
+        <p:spPr>
+          <a:xfrm xmlns:a="http://schemas.openxmlformats.org/drawingml/2006/main">
+            <a:off x="1371600" y="2809875"/>
+            <a:ext cx="2114550" cy="400050"/>
+          </a:xfrm>
+          <a:prstGeom xmlns:a="http://schemas.openxmlformats.org/drawingml/2006/main" prst="rect">
+            <a:avLst/>
+          </a:prstGeom>
+          <a:solidFill xmlns:a="http://schemas.openxmlformats.org/drawingml/2006/main">
+            <a:srgbClr val="F4F7FB"/>
+          </a:solidFill>
+          <a:ln xmlns:a="http://schemas.openxmlformats.org/drawingml/2006/main" w="9525">
+            <a:solidFill>
+              <a:srgbClr val="F4F7FB"/>
+            </a:solidFill>
+            <a:prstDash val="solid"/>
+          </a:ln>
+        </p:spPr>
+        <p:txBody>
+          <a:bodyPr xmlns:a="http://schemas.openxmlformats.org/drawingml/2006/main" lIns="95250" tIns="57150" rIns="95250" bIns="57150" anchor="t"/>
+          <a:lstStyle xmlns:a="http://schemas.openxmlformats.org/drawingml/2006/main"/>
+          <a:p xmlns:a="http://schemas.openxmlformats.org/drawingml/2006/main">
+            <a:pPr algn="l">
+              <a:defRPr sz="1050" b="0">
+                <a:solidFill>
+                  <a:srgbClr val="667085"/>
+                </a:solidFill>
+                <a:latin typeface="Aptos"/>
+                <a:ea typeface="Aptos"/>
+                <a:cs typeface="Aptos"/>
+              </a:defRPr>
+            </a:pPr>
+            <a:r>
+              <a:rPr sz="1050" b="0">
+                <a:solidFill>
+                  <a:srgbClr val="667085"/>
+                </a:solidFill>
+                <a:latin typeface="Aptos"/>
+                <a:ea typeface="Aptos"/>
+                <a:cs typeface="Aptos"/>
+              </a:rPr>
+              <a:t>Base dense Recall@10</a:t>
+            </a:r>
+          </a:p>
+        </p:txBody>
+      </p:sp>
+      <p:sp>
+        <p:nvSpPr>
+          <p:cNvPr id="7" name="">
+            <a:extLst xmlns:a="http://schemas.openxmlformats.org/drawingml/2006/main">
+              <a:ext uri="{FF2B5EF4-FFF2-40B4-BE49-F238E27FC236}">
+                <a16:creationId xmlns:a16="http://schemas.microsoft.com/office/drawing/2014/main" id="{E8A28EFF-1B2B-4BCC-949D-166A6A640562}"/>
+              </a:ext>
+            </a:extLst>
+          </p:cNvPr>
+          <p:cNvSpPr>
+            <a:spLocks xmlns:a="http://schemas.openxmlformats.org/drawingml/2006/main" noGrp="1"/>
+          </p:cNvSpPr>
+          <p:nvPr/>
+        </p:nvSpPr>
+        <p:spPr>
+          <a:xfrm xmlns:a="http://schemas.openxmlformats.org/drawingml/2006/main">
+            <a:off x="4238625" y="2238375"/>
+            <a:ext cx="2381250" cy="1143000"/>
           </a:xfrm>
           <a:prstGeom xmlns:a="http://schemas.openxmlformats.org/drawingml/2006/main" prst="rect">
             <a:avLst/>
@@ -8100,22 +8346,22 @@
       </p:sp>
       <p:sp>
         <p:nvSpPr>
-          <p:cNvPr id="6" name="">
-            <a:extLst xmlns:a="http://schemas.openxmlformats.org/drawingml/2006/main">
-              <a:ext uri="{FF2B5EF4-FFF2-40B4-BE49-F238E27FC236}">
-                <a16:creationId xmlns:a16="http://schemas.microsoft.com/office/drawing/2014/main" id="{35DEC855-3541-4D10-9C9E-D89E49965DFF}"/>
-              </a:ext>
-            </a:extLst>
-          </p:cNvPr>
-          <p:cNvSpPr>
-            <a:spLocks xmlns:a="http://schemas.openxmlformats.org/drawingml/2006/main" noGrp="1"/>
-          </p:cNvSpPr>
-          <p:nvPr/>
-        </p:nvSpPr>
-        <p:spPr>
-          <a:xfrm xmlns:a="http://schemas.openxmlformats.org/drawingml/2006/main">
-            <a:off x="1123950" y="3048000"/>
-            <a:ext cx="2038350" cy="285750"/>
+          <p:cNvPr id="8" name="">
+            <a:extLst xmlns:a="http://schemas.openxmlformats.org/drawingml/2006/main">
+              <a:ext uri="{FF2B5EF4-FFF2-40B4-BE49-F238E27FC236}">
+                <a16:creationId xmlns:a16="http://schemas.microsoft.com/office/drawing/2014/main" id="{9FA87A41-06F2-4806-9DD3-D8675B1F2F5D}"/>
+              </a:ext>
+            </a:extLst>
+          </p:cNvPr>
+          <p:cNvSpPr>
+            <a:spLocks xmlns:a="http://schemas.openxmlformats.org/drawingml/2006/main" noGrp="1"/>
+          </p:cNvSpPr>
+          <p:nvPr/>
+        </p:nvSpPr>
+        <p:spPr>
+          <a:xfrm xmlns:a="http://schemas.openxmlformats.org/drawingml/2006/main">
+            <a:off x="4371975" y="2371725"/>
+            <a:ext cx="2114550" cy="419100"/>
           </a:xfrm>
           <a:prstGeom xmlns:a="http://schemas.openxmlformats.org/drawingml/2006/main" prst="rect">
             <a:avLst/>
@@ -8134,8 +8380,281 @@
           <a:bodyPr xmlns:a="http://schemas.openxmlformats.org/drawingml/2006/main" lIns="95250" tIns="57150" rIns="95250" bIns="57150" anchor="t"/>
           <a:lstStyle xmlns:a="http://schemas.openxmlformats.org/drawingml/2006/main"/>
           <a:p xmlns:a="http://schemas.openxmlformats.org/drawingml/2006/main">
+            <a:pPr algn="l">
+              <a:defRPr sz="2250" b="1">
+                <a:solidFill>
+                  <a:srgbClr val="B42318"/>
+                </a:solidFill>
+                <a:latin typeface="Aptos"/>
+                <a:ea typeface="Aptos"/>
+                <a:cs typeface="Aptos"/>
+              </a:defRPr>
+            </a:pPr>
+            <a:r>
+              <a:rPr sz="2250" b="1">
+                <a:solidFill>
+                  <a:srgbClr val="B42318"/>
+                </a:solidFill>
+                <a:latin typeface="Aptos"/>
+                <a:ea typeface="Aptos"/>
+                <a:cs typeface="Aptos"/>
+              </a:rPr>
+              <a:t>0.591</a:t>
+            </a:r>
+          </a:p>
+        </p:txBody>
+      </p:sp>
+      <p:sp>
+        <p:nvSpPr>
+          <p:cNvPr id="9" name="">
+            <a:extLst xmlns:a="http://schemas.openxmlformats.org/drawingml/2006/main">
+              <a:ext uri="{FF2B5EF4-FFF2-40B4-BE49-F238E27FC236}">
+                <a16:creationId xmlns:a16="http://schemas.microsoft.com/office/drawing/2014/main" id="{E581F18D-A07B-496D-A301-CFDE86B925C6}"/>
+              </a:ext>
+            </a:extLst>
+          </p:cNvPr>
+          <p:cNvSpPr>
+            <a:spLocks xmlns:a="http://schemas.openxmlformats.org/drawingml/2006/main" noGrp="1"/>
+          </p:cNvSpPr>
+          <p:nvPr/>
+        </p:nvSpPr>
+        <p:spPr>
+          <a:xfrm xmlns:a="http://schemas.openxmlformats.org/drawingml/2006/main">
+            <a:off x="4371975" y="2809875"/>
+            <a:ext cx="2114550" cy="400050"/>
+          </a:xfrm>
+          <a:prstGeom xmlns:a="http://schemas.openxmlformats.org/drawingml/2006/main" prst="rect">
+            <a:avLst/>
+          </a:prstGeom>
+          <a:solidFill xmlns:a="http://schemas.openxmlformats.org/drawingml/2006/main">
+            <a:srgbClr val="F4F7FB"/>
+          </a:solidFill>
+          <a:ln xmlns:a="http://schemas.openxmlformats.org/drawingml/2006/main" w="9525">
+            <a:solidFill>
+              <a:srgbClr val="F4F7FB"/>
+            </a:solidFill>
+            <a:prstDash val="solid"/>
+          </a:ln>
+        </p:spPr>
+        <p:txBody>
+          <a:bodyPr xmlns:a="http://schemas.openxmlformats.org/drawingml/2006/main" lIns="95250" tIns="57150" rIns="95250" bIns="57150" anchor="t"/>
+          <a:lstStyle xmlns:a="http://schemas.openxmlformats.org/drawingml/2006/main"/>
+          <a:p xmlns:a="http://schemas.openxmlformats.org/drawingml/2006/main">
+            <a:pPr algn="l">
+              <a:defRPr sz="1050" b="0">
+                <a:solidFill>
+                  <a:srgbClr val="667085"/>
+                </a:solidFill>
+                <a:latin typeface="Aptos"/>
+                <a:ea typeface="Aptos"/>
+                <a:cs typeface="Aptos"/>
+              </a:defRPr>
+            </a:pPr>
+            <a:r>
+              <a:rPr sz="1050" b="0">
+                <a:solidFill>
+                  <a:srgbClr val="667085"/>
+                </a:solidFill>
+                <a:latin typeface="Aptos"/>
+                <a:ea typeface="Aptos"/>
+                <a:cs typeface="Aptos"/>
+              </a:rPr>
+              <a:t>CPU triplet tuned Recall@10</a:t>
+            </a:r>
+          </a:p>
+        </p:txBody>
+      </p:sp>
+      <p:sp>
+        <p:nvSpPr>
+          <p:cNvPr id="10" name="">
+            <a:extLst xmlns:a="http://schemas.openxmlformats.org/drawingml/2006/main">
+              <a:ext uri="{FF2B5EF4-FFF2-40B4-BE49-F238E27FC236}">
+                <a16:creationId xmlns:a16="http://schemas.microsoft.com/office/drawing/2014/main" id="{E439E0EF-C7FB-471B-8B6E-00D4F9204467}"/>
+              </a:ext>
+            </a:extLst>
+          </p:cNvPr>
+          <p:cNvSpPr>
+            <a:spLocks xmlns:a="http://schemas.openxmlformats.org/drawingml/2006/main" noGrp="1"/>
+          </p:cNvSpPr>
+          <p:nvPr/>
+        </p:nvSpPr>
+        <p:spPr>
+          <a:xfrm xmlns:a="http://schemas.openxmlformats.org/drawingml/2006/main">
+            <a:off x="7239000" y="2238375"/>
+            <a:ext cx="2381250" cy="1143000"/>
+          </a:xfrm>
+          <a:prstGeom xmlns:a="http://schemas.openxmlformats.org/drawingml/2006/main" prst="rect">
+            <a:avLst/>
+          </a:prstGeom>
+          <a:solidFill xmlns:a="http://schemas.openxmlformats.org/drawingml/2006/main">
+            <a:srgbClr val="F4F7FB"/>
+          </a:solidFill>
+          <a:ln xmlns:a="http://schemas.openxmlformats.org/drawingml/2006/main" w="9525">
+            <a:solidFill>
+              <a:srgbClr val="D6DEE9"/>
+            </a:solidFill>
+            <a:prstDash val="solid"/>
+          </a:ln>
+        </p:spPr>
+      </p:sp>
+      <p:sp>
+        <p:nvSpPr>
+          <p:cNvPr id="11" name="">
+            <a:extLst xmlns:a="http://schemas.openxmlformats.org/drawingml/2006/main">
+              <a:ext uri="{FF2B5EF4-FFF2-40B4-BE49-F238E27FC236}">
+                <a16:creationId xmlns:a16="http://schemas.microsoft.com/office/drawing/2014/main" id="{E1B03331-3DDD-43EF-ACCB-B4EA4DFC9F9C}"/>
+              </a:ext>
+            </a:extLst>
+          </p:cNvPr>
+          <p:cNvSpPr>
+            <a:spLocks xmlns:a="http://schemas.openxmlformats.org/drawingml/2006/main" noGrp="1"/>
+          </p:cNvSpPr>
+          <p:nvPr/>
+        </p:nvSpPr>
+        <p:spPr>
+          <a:xfrm xmlns:a="http://schemas.openxmlformats.org/drawingml/2006/main">
+            <a:off x="7372350" y="2371725"/>
+            <a:ext cx="2114550" cy="419100"/>
+          </a:xfrm>
+          <a:prstGeom xmlns:a="http://schemas.openxmlformats.org/drawingml/2006/main" prst="rect">
+            <a:avLst/>
+          </a:prstGeom>
+          <a:solidFill xmlns:a="http://schemas.openxmlformats.org/drawingml/2006/main">
+            <a:srgbClr val="F4F7FB"/>
+          </a:solidFill>
+          <a:ln xmlns:a="http://schemas.openxmlformats.org/drawingml/2006/main" w="9525">
+            <a:solidFill>
+              <a:srgbClr val="F4F7FB"/>
+            </a:solidFill>
+            <a:prstDash val="solid"/>
+          </a:ln>
+        </p:spPr>
+        <p:txBody>
+          <a:bodyPr xmlns:a="http://schemas.openxmlformats.org/drawingml/2006/main" lIns="95250" tIns="57150" rIns="95250" bIns="57150" anchor="t"/>
+          <a:lstStyle xmlns:a="http://schemas.openxmlformats.org/drawingml/2006/main"/>
+          <a:p xmlns:a="http://schemas.openxmlformats.org/drawingml/2006/main">
+            <a:pPr algn="l">
+              <a:defRPr sz="2250" b="1">
+                <a:solidFill>
+                  <a:srgbClr val="B7791F"/>
+                </a:solidFill>
+                <a:latin typeface="Aptos"/>
+                <a:ea typeface="Aptos"/>
+                <a:cs typeface="Aptos"/>
+              </a:defRPr>
+            </a:pPr>
+            <a:r>
+              <a:rPr sz="2250" b="1">
+                <a:solidFill>
+                  <a:srgbClr val="B7791F"/>
+                </a:solidFill>
+                <a:latin typeface="Aptos"/>
+                <a:ea typeface="Aptos"/>
+                <a:cs typeface="Aptos"/>
+              </a:rPr>
+              <a:t>41 min</a:t>
+            </a:r>
+          </a:p>
+        </p:txBody>
+      </p:sp>
+      <p:sp>
+        <p:nvSpPr>
+          <p:cNvPr id="12" name="">
+            <a:extLst xmlns:a="http://schemas.openxmlformats.org/drawingml/2006/main">
+              <a:ext uri="{FF2B5EF4-FFF2-40B4-BE49-F238E27FC236}">
+                <a16:creationId xmlns:a16="http://schemas.microsoft.com/office/drawing/2014/main" id="{785F3BC2-4650-4ED3-9078-1A2582D29DAC}"/>
+              </a:ext>
+            </a:extLst>
+          </p:cNvPr>
+          <p:cNvSpPr>
+            <a:spLocks xmlns:a="http://schemas.openxmlformats.org/drawingml/2006/main" noGrp="1"/>
+          </p:cNvSpPr>
+          <p:nvPr/>
+        </p:nvSpPr>
+        <p:spPr>
+          <a:xfrm xmlns:a="http://schemas.openxmlformats.org/drawingml/2006/main">
+            <a:off x="7372350" y="2809875"/>
+            <a:ext cx="2114550" cy="400050"/>
+          </a:xfrm>
+          <a:prstGeom xmlns:a="http://schemas.openxmlformats.org/drawingml/2006/main" prst="rect">
+            <a:avLst/>
+          </a:prstGeom>
+          <a:solidFill xmlns:a="http://schemas.openxmlformats.org/drawingml/2006/main">
+            <a:srgbClr val="F4F7FB"/>
+          </a:solidFill>
+          <a:ln xmlns:a="http://schemas.openxmlformats.org/drawingml/2006/main" w="9525">
+            <a:solidFill>
+              <a:srgbClr val="F4F7FB"/>
+            </a:solidFill>
+            <a:prstDash val="solid"/>
+          </a:ln>
+        </p:spPr>
+        <p:txBody>
+          <a:bodyPr xmlns:a="http://schemas.openxmlformats.org/drawingml/2006/main" lIns="95250" tIns="57150" rIns="95250" bIns="57150" anchor="t"/>
+          <a:lstStyle xmlns:a="http://schemas.openxmlformats.org/drawingml/2006/main"/>
+          <a:p xmlns:a="http://schemas.openxmlformats.org/drawingml/2006/main">
+            <a:pPr algn="l">
+              <a:defRPr sz="1050" b="0">
+                <a:solidFill>
+                  <a:srgbClr val="667085"/>
+                </a:solidFill>
+                <a:latin typeface="Aptos"/>
+                <a:ea typeface="Aptos"/>
+                <a:cs typeface="Aptos"/>
+              </a:defRPr>
+            </a:pPr>
+            <a:r>
+              <a:rPr sz="1050" b="0">
+                <a:solidFill>
+                  <a:srgbClr val="667085"/>
+                </a:solidFill>
+                <a:latin typeface="Aptos"/>
+                <a:ea typeface="Aptos"/>
+                <a:cs typeface="Aptos"/>
+              </a:rPr>
+              <a:t>CPU training runtime</a:t>
+            </a:r>
+          </a:p>
+        </p:txBody>
+      </p:sp>
+      <p:sp>
+        <p:nvSpPr>
+          <p:cNvPr id="13" name="">
+            <a:extLst xmlns:a="http://schemas.openxmlformats.org/drawingml/2006/main">
+              <a:ext uri="{FF2B5EF4-FFF2-40B4-BE49-F238E27FC236}">
+                <a16:creationId xmlns:a16="http://schemas.microsoft.com/office/drawing/2014/main" id="{9B2302F7-1806-4098-851E-5D24E40D63DD}"/>
+              </a:ext>
+            </a:extLst>
+          </p:cNvPr>
+          <p:cNvSpPr>
+            <a:spLocks xmlns:a="http://schemas.openxmlformats.org/drawingml/2006/main" noGrp="1"/>
+          </p:cNvSpPr>
+          <p:nvPr/>
+        </p:nvSpPr>
+        <p:spPr>
+          <a:xfrm xmlns:a="http://schemas.openxmlformats.org/drawingml/2006/main">
+            <a:off x="1381125" y="4333875"/>
+            <a:ext cx="8572500" cy="800100"/>
+          </a:xfrm>
+          <a:prstGeom xmlns:a="http://schemas.openxmlformats.org/drawingml/2006/main" prst="rect">
+            <a:avLst/>
+          </a:prstGeom>
+          <a:solidFill xmlns:a="http://schemas.openxmlformats.org/drawingml/2006/main">
+            <a:srgbClr val="FFF1F0"/>
+          </a:solidFill>
+          <a:ln xmlns:a="http://schemas.openxmlformats.org/drawingml/2006/main" w="9525">
+            <a:solidFill>
+              <a:srgbClr val="FDA29B"/>
+            </a:solidFill>
+            <a:prstDash val="solid"/>
+          </a:ln>
+        </p:spPr>
+        <p:txBody>
+          <a:bodyPr xmlns:a="http://schemas.openxmlformats.org/drawingml/2006/main" lIns="95250" tIns="57150" rIns="95250" bIns="57150" anchor="t"/>
+          <a:lstStyle xmlns:a="http://schemas.openxmlformats.org/drawingml/2006/main"/>
+          <a:p xmlns:a="http://schemas.openxmlformats.org/drawingml/2006/main">
             <a:pPr algn="ctr">
-              <a:defRPr sz="1350" b="1">
+              <a:defRPr sz="1725" b="1">
                 <a:solidFill>
                   <a:srgbClr val="0B2545"/>
                 </a:solidFill>
@@ -8145,7 +8664,7 @@
               </a:defRPr>
             </a:pPr>
             <a:r>
-              <a:rPr sz="1350" b="1">
+              <a:rPr sz="1725" b="1">
                 <a:solidFill>
                   <a:srgbClr val="0B2545"/>
                 </a:solidFill>
@@ -8153,319 +8672,7 @@
                 <a:ea typeface="Aptos"/>
                 <a:cs typeface="Aptos"/>
               </a:rPr>
-              <a:t>query</a:t>
-            </a:r>
-          </a:p>
-        </p:txBody>
-      </p:sp>
-      <p:sp>
-        <p:nvSpPr>
-          <p:cNvPr id="7" name="">
-            <a:extLst xmlns:a="http://schemas.openxmlformats.org/drawingml/2006/main">
-              <a:ext uri="{FF2B5EF4-FFF2-40B4-BE49-F238E27FC236}">
-                <a16:creationId xmlns:a16="http://schemas.microsoft.com/office/drawing/2014/main" id="{970A4014-51DD-4095-97FD-071D74C43CFF}"/>
-              </a:ext>
-            </a:extLst>
-          </p:cNvPr>
-          <p:cNvSpPr>
-            <a:spLocks xmlns:a="http://schemas.openxmlformats.org/drawingml/2006/main" noGrp="1"/>
-          </p:cNvSpPr>
-          <p:nvPr/>
-        </p:nvSpPr>
-        <p:spPr>
-          <a:xfrm xmlns:a="http://schemas.openxmlformats.org/drawingml/2006/main">
-            <a:off x="3409950" y="3162300"/>
-            <a:ext cx="533400" cy="38100"/>
-          </a:xfrm>
-          <a:prstGeom xmlns:a="http://schemas.openxmlformats.org/drawingml/2006/main" prst="rect">
-            <a:avLst/>
-          </a:prstGeom>
-          <a:solidFill xmlns:a="http://schemas.openxmlformats.org/drawingml/2006/main">
-            <a:srgbClr val="B7791F"/>
-          </a:solidFill>
-          <a:ln xmlns:a="http://schemas.openxmlformats.org/drawingml/2006/main" w="9525">
-            <a:solidFill>
-              <a:srgbClr val="B7791F"/>
-            </a:solidFill>
-            <a:prstDash val="solid"/>
-          </a:ln>
-        </p:spPr>
-      </p:sp>
-      <p:sp>
-        <p:nvSpPr>
-          <p:cNvPr id="8" name="">
-            <a:extLst xmlns:a="http://schemas.openxmlformats.org/drawingml/2006/main">
-              <a:ext uri="{FF2B5EF4-FFF2-40B4-BE49-F238E27FC236}">
-                <a16:creationId xmlns:a16="http://schemas.microsoft.com/office/drawing/2014/main" id="{8607F5E2-D303-4830-B7F4-5C6BDEE5941D}"/>
-              </a:ext>
-            </a:extLst>
-          </p:cNvPr>
-          <p:cNvSpPr>
-            <a:spLocks xmlns:a="http://schemas.openxmlformats.org/drawingml/2006/main" noGrp="1"/>
-          </p:cNvSpPr>
-          <p:nvPr/>
-        </p:nvSpPr>
-        <p:spPr>
-          <a:xfrm xmlns:a="http://schemas.openxmlformats.org/drawingml/2006/main">
-            <a:off x="4095750" y="2857500"/>
-            <a:ext cx="2381250" cy="666750"/>
-          </a:xfrm>
-          <a:prstGeom xmlns:a="http://schemas.openxmlformats.org/drawingml/2006/main" prst="rect">
-            <a:avLst/>
-          </a:prstGeom>
-          <a:solidFill xmlns:a="http://schemas.openxmlformats.org/drawingml/2006/main">
-            <a:srgbClr val="F4F7FB"/>
-          </a:solidFill>
-          <a:ln xmlns:a="http://schemas.openxmlformats.org/drawingml/2006/main" w="9525">
-            <a:solidFill>
-              <a:srgbClr val="D6DEE9"/>
-            </a:solidFill>
-            <a:prstDash val="solid"/>
-          </a:ln>
-        </p:spPr>
-      </p:sp>
-      <p:sp>
-        <p:nvSpPr>
-          <p:cNvPr id="9" name="">
-            <a:extLst xmlns:a="http://schemas.openxmlformats.org/drawingml/2006/main">
-              <a:ext uri="{FF2B5EF4-FFF2-40B4-BE49-F238E27FC236}">
-                <a16:creationId xmlns:a16="http://schemas.microsoft.com/office/drawing/2014/main" id="{0D04E584-1DB6-4ED7-9571-7A5312820CE0}"/>
-              </a:ext>
-            </a:extLst>
-          </p:cNvPr>
-          <p:cNvSpPr>
-            <a:spLocks xmlns:a="http://schemas.openxmlformats.org/drawingml/2006/main" noGrp="1"/>
-          </p:cNvSpPr>
-          <p:nvPr/>
-        </p:nvSpPr>
-        <p:spPr>
-          <a:xfrm xmlns:a="http://schemas.openxmlformats.org/drawingml/2006/main">
-            <a:off x="4267200" y="3048000"/>
-            <a:ext cx="2038350" cy="285750"/>
-          </a:xfrm>
-          <a:prstGeom xmlns:a="http://schemas.openxmlformats.org/drawingml/2006/main" prst="rect">
-            <a:avLst/>
-          </a:prstGeom>
-          <a:solidFill xmlns:a="http://schemas.openxmlformats.org/drawingml/2006/main">
-            <a:srgbClr val="F4F7FB"/>
-          </a:solidFill>
-          <a:ln xmlns:a="http://schemas.openxmlformats.org/drawingml/2006/main" w="9525">
-            <a:solidFill>
-              <a:srgbClr val="F4F7FB"/>
-            </a:solidFill>
-            <a:prstDash val="solid"/>
-          </a:ln>
-        </p:spPr>
-        <p:txBody>
-          <a:bodyPr xmlns:a="http://schemas.openxmlformats.org/drawingml/2006/main" lIns="95250" tIns="57150" rIns="95250" bIns="57150" anchor="t"/>
-          <a:lstStyle xmlns:a="http://schemas.openxmlformats.org/drawingml/2006/main"/>
-          <a:p xmlns:a="http://schemas.openxmlformats.org/drawingml/2006/main">
-            <a:pPr algn="ctr">
-              <a:defRPr sz="1350" b="1">
-                <a:solidFill>
-                  <a:srgbClr val="0B2545"/>
-                </a:solidFill>
-                <a:latin typeface="Aptos"/>
-                <a:ea typeface="Aptos"/>
-                <a:cs typeface="Aptos"/>
-              </a:defRPr>
-            </a:pPr>
-            <a:r>
-              <a:rPr sz="1350" b="1">
-                <a:solidFill>
-                  <a:srgbClr val="0B2545"/>
-                </a:solidFill>
-                <a:latin typeface="Aptos"/>
-                <a:ea typeface="Aptos"/>
-                <a:cs typeface="Aptos"/>
-              </a:rPr>
-              <a:t>positive passage</a:t>
-            </a:r>
-          </a:p>
-        </p:txBody>
-      </p:sp>
-      <p:sp>
-        <p:nvSpPr>
-          <p:cNvPr id="10" name="">
-            <a:extLst xmlns:a="http://schemas.openxmlformats.org/drawingml/2006/main">
-              <a:ext uri="{FF2B5EF4-FFF2-40B4-BE49-F238E27FC236}">
-                <a16:creationId xmlns:a16="http://schemas.microsoft.com/office/drawing/2014/main" id="{5BFF8790-CADA-43CA-B4F0-06798D900493}"/>
-              </a:ext>
-            </a:extLst>
-          </p:cNvPr>
-          <p:cNvSpPr>
-            <a:spLocks xmlns:a="http://schemas.openxmlformats.org/drawingml/2006/main" noGrp="1"/>
-          </p:cNvSpPr>
-          <p:nvPr/>
-        </p:nvSpPr>
-        <p:spPr>
-          <a:xfrm xmlns:a="http://schemas.openxmlformats.org/drawingml/2006/main">
-            <a:off x="6553200" y="3162300"/>
-            <a:ext cx="533400" cy="38100"/>
-          </a:xfrm>
-          <a:prstGeom xmlns:a="http://schemas.openxmlformats.org/drawingml/2006/main" prst="rect">
-            <a:avLst/>
-          </a:prstGeom>
-          <a:solidFill xmlns:a="http://schemas.openxmlformats.org/drawingml/2006/main">
-            <a:srgbClr val="B7791F"/>
-          </a:solidFill>
-          <a:ln xmlns:a="http://schemas.openxmlformats.org/drawingml/2006/main" w="9525">
-            <a:solidFill>
-              <a:srgbClr val="B7791F"/>
-            </a:solidFill>
-            <a:prstDash val="solid"/>
-          </a:ln>
-        </p:spPr>
-      </p:sp>
-      <p:sp>
-        <p:nvSpPr>
-          <p:cNvPr id="11" name="">
-            <a:extLst xmlns:a="http://schemas.openxmlformats.org/drawingml/2006/main">
-              <a:ext uri="{FF2B5EF4-FFF2-40B4-BE49-F238E27FC236}">
-                <a16:creationId xmlns:a16="http://schemas.microsoft.com/office/drawing/2014/main" id="{D0B244BF-8D15-40CD-B668-1885D21A2355}"/>
-              </a:ext>
-            </a:extLst>
-          </p:cNvPr>
-          <p:cNvSpPr>
-            <a:spLocks xmlns:a="http://schemas.openxmlformats.org/drawingml/2006/main" noGrp="1"/>
-          </p:cNvSpPr>
-          <p:nvPr/>
-        </p:nvSpPr>
-        <p:spPr>
-          <a:xfrm xmlns:a="http://schemas.openxmlformats.org/drawingml/2006/main">
-            <a:off x="7239000" y="2857500"/>
-            <a:ext cx="2381250" cy="666750"/>
-          </a:xfrm>
-          <a:prstGeom xmlns:a="http://schemas.openxmlformats.org/drawingml/2006/main" prst="rect">
-            <a:avLst/>
-          </a:prstGeom>
-          <a:solidFill xmlns:a="http://schemas.openxmlformats.org/drawingml/2006/main">
-            <a:srgbClr val="F4F7FB"/>
-          </a:solidFill>
-          <a:ln xmlns:a="http://schemas.openxmlformats.org/drawingml/2006/main" w="9525">
-            <a:solidFill>
-              <a:srgbClr val="D6DEE9"/>
-            </a:solidFill>
-            <a:prstDash val="solid"/>
-          </a:ln>
-        </p:spPr>
-      </p:sp>
-      <p:sp>
-        <p:nvSpPr>
-          <p:cNvPr id="12" name="">
-            <a:extLst xmlns:a="http://schemas.openxmlformats.org/drawingml/2006/main">
-              <a:ext uri="{FF2B5EF4-FFF2-40B4-BE49-F238E27FC236}">
-                <a16:creationId xmlns:a16="http://schemas.microsoft.com/office/drawing/2014/main" id="{993991AC-7E19-410C-824D-9A1AF3A20386}"/>
-              </a:ext>
-            </a:extLst>
-          </p:cNvPr>
-          <p:cNvSpPr>
-            <a:spLocks xmlns:a="http://schemas.openxmlformats.org/drawingml/2006/main" noGrp="1"/>
-          </p:cNvSpPr>
-          <p:nvPr/>
-        </p:nvSpPr>
-        <p:spPr>
-          <a:xfrm xmlns:a="http://schemas.openxmlformats.org/drawingml/2006/main">
-            <a:off x="7410450" y="3048000"/>
-            <a:ext cx="2038350" cy="285750"/>
-          </a:xfrm>
-          <a:prstGeom xmlns:a="http://schemas.openxmlformats.org/drawingml/2006/main" prst="rect">
-            <a:avLst/>
-          </a:prstGeom>
-          <a:solidFill xmlns:a="http://schemas.openxmlformats.org/drawingml/2006/main">
-            <a:srgbClr val="F4F7FB"/>
-          </a:solidFill>
-          <a:ln xmlns:a="http://schemas.openxmlformats.org/drawingml/2006/main" w="9525">
-            <a:solidFill>
-              <a:srgbClr val="F4F7FB"/>
-            </a:solidFill>
-            <a:prstDash val="solid"/>
-          </a:ln>
-        </p:spPr>
-        <p:txBody>
-          <a:bodyPr xmlns:a="http://schemas.openxmlformats.org/drawingml/2006/main" lIns="95250" tIns="57150" rIns="95250" bIns="57150" anchor="t"/>
-          <a:lstStyle xmlns:a="http://schemas.openxmlformats.org/drawingml/2006/main"/>
-          <a:p xmlns:a="http://schemas.openxmlformats.org/drawingml/2006/main">
-            <a:pPr algn="ctr">
-              <a:defRPr sz="1350" b="1">
-                <a:solidFill>
-                  <a:srgbClr val="0B2545"/>
-                </a:solidFill>
-                <a:latin typeface="Aptos"/>
-                <a:ea typeface="Aptos"/>
-                <a:cs typeface="Aptos"/>
-              </a:defRPr>
-            </a:pPr>
-            <a:r>
-              <a:rPr sz="1350" b="1">
-                <a:solidFill>
-                  <a:srgbClr val="0B2545"/>
-                </a:solidFill>
-                <a:latin typeface="Aptos"/>
-                <a:ea typeface="Aptos"/>
-                <a:cs typeface="Aptos"/>
-              </a:rPr>
-              <a:t>hard negative passage</a:t>
-            </a:r>
-          </a:p>
-        </p:txBody>
-      </p:sp>
-      <p:sp>
-        <p:nvSpPr>
-          <p:cNvPr id="13" name="">
-            <a:extLst xmlns:a="http://schemas.openxmlformats.org/drawingml/2006/main">
-              <a:ext uri="{FF2B5EF4-FFF2-40B4-BE49-F238E27FC236}">
-                <a16:creationId xmlns:a16="http://schemas.microsoft.com/office/drawing/2014/main" id="{AF118172-A35F-43AF-A127-FC65641DB055}"/>
-              </a:ext>
-            </a:extLst>
-          </p:cNvPr>
-          <p:cNvSpPr>
-            <a:spLocks xmlns:a="http://schemas.openxmlformats.org/drawingml/2006/main" noGrp="1"/>
-          </p:cNvSpPr>
-          <p:nvPr/>
-        </p:nvSpPr>
-        <p:spPr>
-          <a:xfrm xmlns:a="http://schemas.openxmlformats.org/drawingml/2006/main">
-            <a:off x="1333500" y="4524375"/>
-            <a:ext cx="8858250" cy="666750"/>
-          </a:xfrm>
-          <a:prstGeom xmlns:a="http://schemas.openxmlformats.org/drawingml/2006/main" prst="rect">
-            <a:avLst/>
-          </a:prstGeom>
-          <a:solidFill xmlns:a="http://schemas.openxmlformats.org/drawingml/2006/main">
-            <a:srgbClr val="FFFFFF"/>
-          </a:solidFill>
-          <a:ln xmlns:a="http://schemas.openxmlformats.org/drawingml/2006/main" w="9525">
-            <a:solidFill>
-              <a:srgbClr val="FFFFFF"/>
-            </a:solidFill>
-            <a:prstDash val="solid"/>
-          </a:ln>
-        </p:spPr>
-        <p:txBody>
-          <a:bodyPr xmlns:a="http://schemas.openxmlformats.org/drawingml/2006/main" lIns="95250" tIns="57150" rIns="95250" bIns="57150" anchor="t"/>
-          <a:lstStyle xmlns:a="http://schemas.openxmlformats.org/drawingml/2006/main"/>
-          <a:p xmlns:a="http://schemas.openxmlformats.org/drawingml/2006/main">
-            <a:pPr algn="ctr">
-              <a:defRPr sz="1650" b="0">
-                <a:solidFill>
-                  <a:srgbClr val="0B2545"/>
-                </a:solidFill>
-                <a:latin typeface="Aptos"/>
-                <a:ea typeface="Aptos"/>
-                <a:cs typeface="Aptos"/>
-              </a:defRPr>
-            </a:pPr>
-            <a:r>
-              <a:rPr sz="1650" b="0">
-                <a:solidFill>
-                  <a:srgbClr val="0B2545"/>
-                </a:solidFill>
-                <a:latin typeface="Aptos"/>
-                <a:ea typeface="Aptos"/>
-                <a:cs typeface="Aptos"/>
-              </a:rPr>
-              <a:t>Implemented: triplet-loss fine-tuning script. CPU smoke run confirms train/save/load/index/evaluate works end to end.</a:t>
+              <a:t>Result: the naive triplet setup degraded dense retrieval. This is a useful ablation and justifies keeping BM25 in the final demo.</a:t>
             </a:r>
           </a:p>
         </p:txBody>
@@ -8475,7 +8682,7 @@
           <p:cNvPr id="14" name="">
             <a:extLst xmlns:a="http://schemas.openxmlformats.org/drawingml/2006/main">
               <a:ext uri="{FF2B5EF4-FFF2-40B4-BE49-F238E27FC236}">
-                <a16:creationId xmlns:a16="http://schemas.microsoft.com/office/drawing/2014/main" id="{086168C8-5008-40A2-A293-8AD014574C95}"/>
+                <a16:creationId xmlns:a16="http://schemas.microsoft.com/office/drawing/2014/main" id="{DBD484BF-9CCD-44C4-A15C-96B751E547F8}"/>
               </a:ext>
             </a:extLst>
           </p:cNvPr>
@@ -8533,7 +8740,7 @@
     </p:spTree>
     <p:extLst>
       <p:ext uri="{BB962C8B-B14F-4D97-AF65-F5344CB8AC3E}">
-        <p14:creationId xmlns:p14="http://schemas.microsoft.com/office/powerpoint/2010/main" val="816965230"/>
+        <p14:creationId xmlns:p14="http://schemas.microsoft.com/office/powerpoint/2010/main" val="1780237980"/>
       </p:ext>
     </p:extLst>
   </p:cSld>
@@ -8557,7 +8764,7 @@
           <p:cNvPr id="1" name="">
             <a:extLst xmlns:a="http://schemas.openxmlformats.org/drawingml/2006/main">
               <a:ext uri="{FF2B5EF4-FFF2-40B4-BE49-F238E27FC236}">
-                <a16:creationId xmlns:a16="http://schemas.microsoft.com/office/drawing/2014/main" id="{10ED5FAE-D58B-4338-8C86-586E8ECD4952}"/>
+                <a16:creationId xmlns:a16="http://schemas.microsoft.com/office/drawing/2014/main" id="{D8DC3D8C-5BAF-4D7B-887D-810545F3DA30}"/>
               </a:ext>
             </a:extLst>
           </p:cNvPr>
@@ -8617,7 +8824,7 @@
           <p:cNvPr id="2" name="">
             <a:extLst xmlns:a="http://schemas.openxmlformats.org/drawingml/2006/main">
               <a:ext uri="{FF2B5EF4-FFF2-40B4-BE49-F238E27FC236}">
-                <a16:creationId xmlns:a16="http://schemas.microsoft.com/office/drawing/2014/main" id="{6A099C9A-6A0D-4DE0-80B8-3ABCE8249D35}"/>
+                <a16:creationId xmlns:a16="http://schemas.microsoft.com/office/drawing/2014/main" id="{4B42AA8A-8C38-4596-97F3-6D74269BBCC0}"/>
               </a:ext>
             </a:extLst>
           </p:cNvPr>
@@ -8677,7 +8884,7 @@
           <p:cNvPr id="3" name="">
             <a:extLst xmlns:a="http://schemas.openxmlformats.org/drawingml/2006/main">
               <a:ext uri="{FF2B5EF4-FFF2-40B4-BE49-F238E27FC236}">
-                <a16:creationId xmlns:a16="http://schemas.microsoft.com/office/drawing/2014/main" id="{599C452B-67E2-40CE-B64A-EF51DEE65206}"/>
+                <a16:creationId xmlns:a16="http://schemas.microsoft.com/office/drawing/2014/main" id="{BB65A527-3651-4A30-8013-E80EF5E9713C}"/>
               </a:ext>
             </a:extLst>
           </p:cNvPr>
@@ -8710,7 +8917,7 @@
           <p:cNvPr id="4" name="">
             <a:extLst xmlns:a="http://schemas.openxmlformats.org/drawingml/2006/main">
               <a:ext uri="{FF2B5EF4-FFF2-40B4-BE49-F238E27FC236}">
-                <a16:creationId xmlns:a16="http://schemas.microsoft.com/office/drawing/2014/main" id="{23BAF5CD-8199-4D0A-B149-48B83E0C0DBB}"/>
+                <a16:creationId xmlns:a16="http://schemas.microsoft.com/office/drawing/2014/main" id="{FA8207BC-24C7-446B-99F0-29219F14B6C1}"/>
               </a:ext>
             </a:extLst>
           </p:cNvPr>
@@ -8743,7 +8950,7 @@
           <p:cNvPr id="5" name="">
             <a:extLst xmlns:a="http://schemas.openxmlformats.org/drawingml/2006/main">
               <a:ext uri="{FF2B5EF4-FFF2-40B4-BE49-F238E27FC236}">
-                <a16:creationId xmlns:a16="http://schemas.microsoft.com/office/drawing/2014/main" id="{5019C569-907B-47D3-B9A2-F34DE8E2967A}"/>
+                <a16:creationId xmlns:a16="http://schemas.microsoft.com/office/drawing/2014/main" id="{FF49BCC1-4AF4-4964-8FC3-D1F17B857AFA}"/>
               </a:ext>
             </a:extLst>
           </p:cNvPr>
@@ -8803,7 +9010,7 @@
           <p:cNvPr id="6" name="">
             <a:extLst xmlns:a="http://schemas.openxmlformats.org/drawingml/2006/main">
               <a:ext uri="{FF2B5EF4-FFF2-40B4-BE49-F238E27FC236}">
-                <a16:creationId xmlns:a16="http://schemas.microsoft.com/office/drawing/2014/main" id="{5A4D646D-D053-4E2D-8375-0B543214DAFF}"/>
+                <a16:creationId xmlns:a16="http://schemas.microsoft.com/office/drawing/2014/main" id="{821FC45E-3565-44D9-8CFB-3905CD267B3A}"/>
               </a:ext>
             </a:extLst>
           </p:cNvPr>
@@ -8863,7 +9070,7 @@
           <p:cNvPr id="7" name="">
             <a:extLst xmlns:a="http://schemas.openxmlformats.org/drawingml/2006/main">
               <a:ext uri="{FF2B5EF4-FFF2-40B4-BE49-F238E27FC236}">
-                <a16:creationId xmlns:a16="http://schemas.microsoft.com/office/drawing/2014/main" id="{7B1195C7-9035-41AF-8CE1-C9881B49517D}"/>
+                <a16:creationId xmlns:a16="http://schemas.microsoft.com/office/drawing/2014/main" id="{03F7BC7B-C41F-40EC-BE52-B6A20C33BEC5}"/>
               </a:ext>
             </a:extLst>
           </p:cNvPr>
@@ -8896,7 +9103,7 @@
           <p:cNvPr id="8" name="">
             <a:extLst xmlns:a="http://schemas.openxmlformats.org/drawingml/2006/main">
               <a:ext uri="{FF2B5EF4-FFF2-40B4-BE49-F238E27FC236}">
-                <a16:creationId xmlns:a16="http://schemas.microsoft.com/office/drawing/2014/main" id="{740052E7-CD03-487A-B6C5-6C63DA7B4335}"/>
+                <a16:creationId xmlns:a16="http://schemas.microsoft.com/office/drawing/2014/main" id="{BD5992E7-EBBA-4384-B8B5-C11FBB0D02AB}"/>
               </a:ext>
             </a:extLst>
           </p:cNvPr>
@@ -8956,7 +9163,7 @@
           <p:cNvPr id="9" name="">
             <a:extLst xmlns:a="http://schemas.openxmlformats.org/drawingml/2006/main">
               <a:ext uri="{FF2B5EF4-FFF2-40B4-BE49-F238E27FC236}">
-                <a16:creationId xmlns:a16="http://schemas.microsoft.com/office/drawing/2014/main" id="{A40CAF9B-356C-4F55-96D8-5989A698DC28}"/>
+                <a16:creationId xmlns:a16="http://schemas.microsoft.com/office/drawing/2014/main" id="{B35A5515-D2EE-4EF6-8DDD-FF8B4CF719AC}"/>
               </a:ext>
             </a:extLst>
           </p:cNvPr>
@@ -9016,7 +9223,7 @@
           <p:cNvPr id="10" name="">
             <a:extLst xmlns:a="http://schemas.openxmlformats.org/drawingml/2006/main">
               <a:ext uri="{FF2B5EF4-FFF2-40B4-BE49-F238E27FC236}">
-                <a16:creationId xmlns:a16="http://schemas.microsoft.com/office/drawing/2014/main" id="{545836AE-4A99-4259-8F6B-E406FD58427A}"/>
+                <a16:creationId xmlns:a16="http://schemas.microsoft.com/office/drawing/2014/main" id="{DDFB4098-03EE-41BB-A2FD-F2FBDD523159}"/>
               </a:ext>
             </a:extLst>
           </p:cNvPr>
@@ -9049,7 +9256,7 @@
           <p:cNvPr id="11" name="">
             <a:extLst xmlns:a="http://schemas.openxmlformats.org/drawingml/2006/main">
               <a:ext uri="{FF2B5EF4-FFF2-40B4-BE49-F238E27FC236}">
-                <a16:creationId xmlns:a16="http://schemas.microsoft.com/office/drawing/2014/main" id="{E57CF46B-6ACB-4703-A03F-3581D54747C9}"/>
+                <a16:creationId xmlns:a16="http://schemas.microsoft.com/office/drawing/2014/main" id="{AB560EFC-42C0-4342-8EBE-A3AC4CA677AB}"/>
               </a:ext>
             </a:extLst>
           </p:cNvPr>
@@ -9109,7 +9316,7 @@
           <p:cNvPr id="12" name="">
             <a:extLst xmlns:a="http://schemas.openxmlformats.org/drawingml/2006/main">
               <a:ext uri="{FF2B5EF4-FFF2-40B4-BE49-F238E27FC236}">
-                <a16:creationId xmlns:a16="http://schemas.microsoft.com/office/drawing/2014/main" id="{40B5D0FF-2686-4360-A0B0-546AEC8EFA45}"/>
+                <a16:creationId xmlns:a16="http://schemas.microsoft.com/office/drawing/2014/main" id="{61D55622-3234-4F66-B579-30E04FA00582}"/>
               </a:ext>
             </a:extLst>
           </p:cNvPr>
@@ -9169,7 +9376,7 @@
           <p:cNvPr id="13" name="">
             <a:extLst xmlns:a="http://schemas.openxmlformats.org/drawingml/2006/main">
               <a:ext uri="{FF2B5EF4-FFF2-40B4-BE49-F238E27FC236}">
-                <a16:creationId xmlns:a16="http://schemas.microsoft.com/office/drawing/2014/main" id="{85821030-1147-411D-B972-01B12E0CC893}"/>
+                <a16:creationId xmlns:a16="http://schemas.microsoft.com/office/drawing/2014/main" id="{89249DDF-176E-4989-A0DD-EA95384EA1DB}"/>
               </a:ext>
             </a:extLst>
           </p:cNvPr>
@@ -9202,7 +9409,7 @@
           <p:cNvPr id="14" name="">
             <a:extLst xmlns:a="http://schemas.openxmlformats.org/drawingml/2006/main">
               <a:ext uri="{FF2B5EF4-FFF2-40B4-BE49-F238E27FC236}">
-                <a16:creationId xmlns:a16="http://schemas.microsoft.com/office/drawing/2014/main" id="{BF8E5298-4495-4585-BE55-7F6E136D87E5}"/>
+                <a16:creationId xmlns:a16="http://schemas.microsoft.com/office/drawing/2014/main" id="{D099A8EA-1BFF-4AE0-A033-BBF1092CAC84}"/>
               </a:ext>
             </a:extLst>
           </p:cNvPr>
@@ -9262,7 +9469,7 @@
           <p:cNvPr id="15" name="">
             <a:extLst xmlns:a="http://schemas.openxmlformats.org/drawingml/2006/main">
               <a:ext uri="{FF2B5EF4-FFF2-40B4-BE49-F238E27FC236}">
-                <a16:creationId xmlns:a16="http://schemas.microsoft.com/office/drawing/2014/main" id="{EF05D072-E825-4A53-AB89-2207223D0411}"/>
+                <a16:creationId xmlns:a16="http://schemas.microsoft.com/office/drawing/2014/main" id="{B7AA9850-D48B-4963-A1CD-7D2F81422A85}"/>
               </a:ext>
             </a:extLst>
           </p:cNvPr>
@@ -9322,7 +9529,7 @@
           <p:cNvPr id="16" name="">
             <a:extLst xmlns:a="http://schemas.openxmlformats.org/drawingml/2006/main">
               <a:ext uri="{FF2B5EF4-FFF2-40B4-BE49-F238E27FC236}">
-                <a16:creationId xmlns:a16="http://schemas.microsoft.com/office/drawing/2014/main" id="{49D814CD-8360-43D3-8353-A5D0A4B36C6A}"/>
+                <a16:creationId xmlns:a16="http://schemas.microsoft.com/office/drawing/2014/main" id="{3F2448BF-37AD-4C0C-9115-022BC95C5288}"/>
               </a:ext>
             </a:extLst>
           </p:cNvPr>
@@ -9372,7 +9579,7 @@
                 <a:ea typeface="Aptos"/>
                 <a:cs typeface="Aptos"/>
               </a:rPr>
-              <a:t>Because the baseline cites the top-1 source, citation accuracy tracks top-1 source hit.</a:t>
+              <a:t>Judge-based faithfulness adds a stricter semantic check: 206 of 240 answers were source-supported, score 0.858.</a:t>
             </a:r>
           </a:p>
         </p:txBody>
@@ -9382,7 +9589,7 @@
           <p:cNvPr id="17" name="">
             <a:extLst xmlns:a="http://schemas.openxmlformats.org/drawingml/2006/main">
               <a:ext uri="{FF2B5EF4-FFF2-40B4-BE49-F238E27FC236}">
-                <a16:creationId xmlns:a16="http://schemas.microsoft.com/office/drawing/2014/main" id="{5B05EDF1-4C59-4F98-948B-254E59968978}"/>
+                <a16:creationId xmlns:a16="http://schemas.microsoft.com/office/drawing/2014/main" id="{59D98A5E-EC59-48E6-B39B-3E5012755266}"/>
               </a:ext>
             </a:extLst>
           </p:cNvPr>
@@ -9440,7 +9647,7 @@
     </p:spTree>
     <p:extLst>
       <p:ext uri="{BB962C8B-B14F-4D97-AF65-F5344CB8AC3E}">
-        <p14:creationId xmlns:p14="http://schemas.microsoft.com/office/powerpoint/2010/main" val="1354193999"/>
+        <p14:creationId xmlns:p14="http://schemas.microsoft.com/office/powerpoint/2010/main" val="162961995"/>
       </p:ext>
     </p:extLst>
   </p:cSld>
@@ -9464,7 +9671,7 @@
           <p:cNvPr id="1" name="">
             <a:extLst xmlns:a="http://schemas.openxmlformats.org/drawingml/2006/main">
               <a:ext uri="{FF2B5EF4-FFF2-40B4-BE49-F238E27FC236}">
-                <a16:creationId xmlns:a16="http://schemas.microsoft.com/office/drawing/2014/main" id="{A03297D1-44B5-4DD2-81C1-A2ADED7121E8}"/>
+                <a16:creationId xmlns:a16="http://schemas.microsoft.com/office/drawing/2014/main" id="{C48C47A5-E9C5-490D-8012-75FAB9368453}"/>
               </a:ext>
             </a:extLst>
           </p:cNvPr>
@@ -9524,7 +9731,7 @@
           <p:cNvPr id="2" name="">
             <a:extLst xmlns:a="http://schemas.openxmlformats.org/drawingml/2006/main">
               <a:ext uri="{FF2B5EF4-FFF2-40B4-BE49-F238E27FC236}">
-                <a16:creationId xmlns:a16="http://schemas.microsoft.com/office/drawing/2014/main" id="{D8608664-32DE-4B9D-8006-73DFECB0C3C7}"/>
+                <a16:creationId xmlns:a16="http://schemas.microsoft.com/office/drawing/2014/main" id="{293FDC9F-41A6-45B9-8D8B-D0FCCB4C5A28}"/>
               </a:ext>
             </a:extLst>
           </p:cNvPr>
@@ -9584,7 +9791,7 @@
           <p:cNvPr id="3" name="">
             <a:extLst xmlns:a="http://schemas.openxmlformats.org/drawingml/2006/main">
               <a:ext uri="{FF2B5EF4-FFF2-40B4-BE49-F238E27FC236}">
-                <a16:creationId xmlns:a16="http://schemas.microsoft.com/office/drawing/2014/main" id="{97391C6D-27FF-4F3B-ACCF-5C64E1D8064A}"/>
+                <a16:creationId xmlns:a16="http://schemas.microsoft.com/office/drawing/2014/main" id="{4CB6B0DE-7B9F-4A93-BE1E-E69E421DE869}"/>
               </a:ext>
             </a:extLst>
           </p:cNvPr>
@@ -9617,7 +9824,7 @@
           <p:cNvPr id="4" name="">
             <a:extLst xmlns:a="http://schemas.openxmlformats.org/drawingml/2006/main">
               <a:ext uri="{FF2B5EF4-FFF2-40B4-BE49-F238E27FC236}">
-                <a16:creationId xmlns:a16="http://schemas.microsoft.com/office/drawing/2014/main" id="{04E32198-FAD8-4A09-872B-E853DC4689EF}"/>
+                <a16:creationId xmlns:a16="http://schemas.microsoft.com/office/drawing/2014/main" id="{3F14ACBA-8B0A-4D92-A0E5-6BBF432D26D6}"/>
               </a:ext>
             </a:extLst>
           </p:cNvPr>
@@ -9650,7 +9857,7 @@
           <p:cNvPr id="5" name="">
             <a:extLst xmlns:a="http://schemas.openxmlformats.org/drawingml/2006/main">
               <a:ext uri="{FF2B5EF4-FFF2-40B4-BE49-F238E27FC236}">
-                <a16:creationId xmlns:a16="http://schemas.microsoft.com/office/drawing/2014/main" id="{FAC492C7-66C2-4185-A549-1E8A9790F1DE}"/>
+                <a16:creationId xmlns:a16="http://schemas.microsoft.com/office/drawing/2014/main" id="{6643AF0F-A675-4459-AA25-640A16938243}"/>
               </a:ext>
             </a:extLst>
           </p:cNvPr>
@@ -9710,7 +9917,7 @@
           <p:cNvPr id="6" name="">
             <a:extLst xmlns:a="http://schemas.openxmlformats.org/drawingml/2006/main">
               <a:ext uri="{FF2B5EF4-FFF2-40B4-BE49-F238E27FC236}">
-                <a16:creationId xmlns:a16="http://schemas.microsoft.com/office/drawing/2014/main" id="{32BEFD11-307B-4C08-B891-D27446FB7DB6}"/>
+                <a16:creationId xmlns:a16="http://schemas.microsoft.com/office/drawing/2014/main" id="{579F2543-491E-4364-B4FF-548CBA3CE5A5}"/>
               </a:ext>
             </a:extLst>
           </p:cNvPr>
@@ -9770,7 +9977,7 @@
           <p:cNvPr id="7" name="">
             <a:extLst xmlns:a="http://schemas.openxmlformats.org/drawingml/2006/main">
               <a:ext uri="{FF2B5EF4-FFF2-40B4-BE49-F238E27FC236}">
-                <a16:creationId xmlns:a16="http://schemas.microsoft.com/office/drawing/2014/main" id="{70E19254-3972-477F-89B9-273F8E4A6576}"/>
+                <a16:creationId xmlns:a16="http://schemas.microsoft.com/office/drawing/2014/main" id="{6009160B-15F2-4C5C-AEBC-E9035ED823F5}"/>
               </a:ext>
             </a:extLst>
           </p:cNvPr>
@@ -9803,7 +10010,7 @@
           <p:cNvPr id="8" name="">
             <a:extLst xmlns:a="http://schemas.openxmlformats.org/drawingml/2006/main">
               <a:ext uri="{FF2B5EF4-FFF2-40B4-BE49-F238E27FC236}">
-                <a16:creationId xmlns:a16="http://schemas.microsoft.com/office/drawing/2014/main" id="{1BB9767B-F724-42E3-A837-736C12643CCE}"/>
+                <a16:creationId xmlns:a16="http://schemas.microsoft.com/office/drawing/2014/main" id="{8B7B7644-562F-4643-86FB-2675BFC71098}"/>
               </a:ext>
             </a:extLst>
           </p:cNvPr>
@@ -9863,7 +10070,7 @@
           <p:cNvPr id="9" name="">
             <a:extLst xmlns:a="http://schemas.openxmlformats.org/drawingml/2006/main">
               <a:ext uri="{FF2B5EF4-FFF2-40B4-BE49-F238E27FC236}">
-                <a16:creationId xmlns:a16="http://schemas.microsoft.com/office/drawing/2014/main" id="{EEF97B39-AD1C-4FF9-B03F-F2C3E8D5AA86}"/>
+                <a16:creationId xmlns:a16="http://schemas.microsoft.com/office/drawing/2014/main" id="{CCB38EA0-F3F4-4488-8A1C-057775DC67AA}"/>
               </a:ext>
             </a:extLst>
           </p:cNvPr>
@@ -9923,7 +10130,7 @@
           <p:cNvPr id="10" name="">
             <a:extLst xmlns:a="http://schemas.openxmlformats.org/drawingml/2006/main">
               <a:ext uri="{FF2B5EF4-FFF2-40B4-BE49-F238E27FC236}">
-                <a16:creationId xmlns:a16="http://schemas.microsoft.com/office/drawing/2014/main" id="{0558436C-24A5-4D98-9D84-47FAD0D54763}"/>
+                <a16:creationId xmlns:a16="http://schemas.microsoft.com/office/drawing/2014/main" id="{F4B09513-63B2-45DE-AC50-12A1726C9E33}"/>
               </a:ext>
             </a:extLst>
           </p:cNvPr>
@@ -9983,7 +10190,7 @@
           <p:cNvPr id="11" name="">
             <a:extLst xmlns:a="http://schemas.openxmlformats.org/drawingml/2006/main">
               <a:ext uri="{FF2B5EF4-FFF2-40B4-BE49-F238E27FC236}">
-                <a16:creationId xmlns:a16="http://schemas.microsoft.com/office/drawing/2014/main" id="{C7704E57-F335-4DAC-B943-02A546F2796F}"/>
+                <a16:creationId xmlns:a16="http://schemas.microsoft.com/office/drawing/2014/main" id="{39F854A1-83A8-427D-A45D-D2F65EAD6DD0}"/>
               </a:ext>
             </a:extLst>
           </p:cNvPr>
@@ -10041,7 +10248,7 @@
     </p:spTree>
     <p:extLst>
       <p:ext uri="{BB962C8B-B14F-4D97-AF65-F5344CB8AC3E}">
-        <p14:creationId xmlns:p14="http://schemas.microsoft.com/office/powerpoint/2010/main" val="412497136"/>
+        <p14:creationId xmlns:p14="http://schemas.microsoft.com/office/powerpoint/2010/main" val="519157498"/>
       </p:ext>
     </p:extLst>
   </p:cSld>

</xml_diff>